<commit_message>
Use Wikimedia FDM visual in slide 2
</commit_message>
<xml_diff>
--- a/presentation_output/ga_boundary_interior_structure.pptx
+++ b/presentation_output/ga_boundary_interior_structure.pptx
@@ -2,23 +2,23 @@
 <file path=ppt/presentation.xml><?xml version="1.0" encoding="utf-8"?>
 <p:presentation xmlns:p="http://schemas.openxmlformats.org/presentationml/2006/main">
   <p:sldMasterIdLst>
-    <p:sldMasterId xmlns:r="http://schemas.openxmlformats.org/officeDocument/2006/relationships" id="2147483648" r:id="R864f491f40c74b4e"/>
+    <p:sldMasterId xmlns:r="http://schemas.openxmlformats.org/officeDocument/2006/relationships" id="2147483648" r:id="Raa655012946e4779"/>
   </p:sldMasterIdLst>
   <p:notesMasterIdLst>
-    <p:notesMasterId xmlns:r="http://schemas.openxmlformats.org/officeDocument/2006/relationships" r:id="R5e1513c2a4f442d8"/>
+    <p:notesMasterId xmlns:r="http://schemas.openxmlformats.org/officeDocument/2006/relationships" r:id="Ra7110ead99944b01"/>
   </p:notesMasterIdLst>
   <p:sldIdLst>
-    <p:sldId xmlns:r="http://schemas.openxmlformats.org/officeDocument/2006/relationships" id="256" r:id="R61f94fca6ac94e9a"/>
-    <p:sldId xmlns:r="http://schemas.openxmlformats.org/officeDocument/2006/relationships" id="257" r:id="Rf3cd6a9ee8f7452b"/>
-    <p:sldId xmlns:r="http://schemas.openxmlformats.org/officeDocument/2006/relationships" id="258" r:id="Rc09570676a07451a"/>
-    <p:sldId xmlns:r="http://schemas.openxmlformats.org/officeDocument/2006/relationships" id="259" r:id="Rc3abedfbab674d07"/>
-    <p:sldId xmlns:r="http://schemas.openxmlformats.org/officeDocument/2006/relationships" id="260" r:id="Rd8fea7799cb14e4f"/>
-    <p:sldId xmlns:r="http://schemas.openxmlformats.org/officeDocument/2006/relationships" id="261" r:id="R066c23b338ac4128"/>
-    <p:sldId xmlns:r="http://schemas.openxmlformats.org/officeDocument/2006/relationships" id="262" r:id="R9295c3ec98c2431f"/>
-    <p:sldId xmlns:r="http://schemas.openxmlformats.org/officeDocument/2006/relationships" id="263" r:id="Rb9ee877733f445ca"/>
-    <p:sldId xmlns:r="http://schemas.openxmlformats.org/officeDocument/2006/relationships" id="264" r:id="Rf540ed8c98cf4160"/>
-    <p:sldId xmlns:r="http://schemas.openxmlformats.org/officeDocument/2006/relationships" id="265" r:id="Re1b298b13a874cf5"/>
-    <p:sldId xmlns:r="http://schemas.openxmlformats.org/officeDocument/2006/relationships" id="266" r:id="Re768042777394af4"/>
+    <p:sldId xmlns:r="http://schemas.openxmlformats.org/officeDocument/2006/relationships" id="256" r:id="R5792c2951bd44911"/>
+    <p:sldId xmlns:r="http://schemas.openxmlformats.org/officeDocument/2006/relationships" id="257" r:id="R2ea2f057742f473e"/>
+    <p:sldId xmlns:r="http://schemas.openxmlformats.org/officeDocument/2006/relationships" id="258" r:id="Rc15c7d64ce0945e2"/>
+    <p:sldId xmlns:r="http://schemas.openxmlformats.org/officeDocument/2006/relationships" id="259" r:id="Rbb77c3fb3f7e409e"/>
+    <p:sldId xmlns:r="http://schemas.openxmlformats.org/officeDocument/2006/relationships" id="260" r:id="R4367781425f14313"/>
+    <p:sldId xmlns:r="http://schemas.openxmlformats.org/officeDocument/2006/relationships" id="261" r:id="R9a702e106e594db4"/>
+    <p:sldId xmlns:r="http://schemas.openxmlformats.org/officeDocument/2006/relationships" id="262" r:id="R92ad1e11c28e4c8e"/>
+    <p:sldId xmlns:r="http://schemas.openxmlformats.org/officeDocument/2006/relationships" id="263" r:id="Rbbb09e56cccb48a2"/>
+    <p:sldId xmlns:r="http://schemas.openxmlformats.org/officeDocument/2006/relationships" id="264" r:id="R726cdf9063344e89"/>
+    <p:sldId xmlns:r="http://schemas.openxmlformats.org/officeDocument/2006/relationships" id="265" r:id="R41ffa9cf2f3f4eb4"/>
+    <p:sldId xmlns:r="http://schemas.openxmlformats.org/officeDocument/2006/relationships" id="266" r:id="R14f40ca4fc1c4e1e"/>
   </p:sldIdLst>
   <p:sldSz cx="12192000" cy="6858000"/>
   <p:notesSz cx="6858000" cy="9144000"/>
@@ -1225,7 +1225,7 @@
   </p:cSld>
   <p:clrMap bg1="lt1" tx1="dk1" bg2="lt2" tx2="dk2" accent1="accent1" accent2="accent2" accent3="accent3" accent4="accent4" accent5="accent5" accent6="accent6" hlink="hlink" folHlink="folHlink"/>
   <p:sldLayoutIdLst>
-    <p:sldLayoutId xmlns:r="http://schemas.openxmlformats.org/officeDocument/2006/relationships" id="2147483649" r:id="R410f4385e3344277"/>
+    <p:sldLayoutId xmlns:r="http://schemas.openxmlformats.org/officeDocument/2006/relationships" id="2147483649" r:id="Rb28bf306206f4aa5"/>
   </p:sldLayoutIdLst>
   <p:txStyles>
     <p:titleStyle>
@@ -1524,7 +1524,7 @@
           <p:cNvPr id="1" name="">
             <a:extLst xmlns:a="http://schemas.openxmlformats.org/drawingml/2006/main">
               <a:ext uri="{FF2B5EF4-FFF2-40B4-BE49-F238E27FC236}">
-                <a16:creationId xmlns:a16="http://schemas.microsoft.com/office/drawing/2014/main" id="{8B402D2B-6DCF-4AC1-971C-1819A72DE0B8}"/>
+                <a16:creationId xmlns:a16="http://schemas.microsoft.com/office/drawing/2014/main" id="{1B69339B-0E3A-4AD0-AD58-C4F7947008E8}"/>
               </a:ext>
             </a:extLst>
           </p:cNvPr>
@@ -1559,7 +1559,7 @@
           <p:cNvPr id="2" name="">
             <a:extLst xmlns:a="http://schemas.openxmlformats.org/drawingml/2006/main">
               <a:ext uri="{FF2B5EF4-FFF2-40B4-BE49-F238E27FC236}">
-                <a16:creationId xmlns:a16="http://schemas.microsoft.com/office/drawing/2014/main" id="{F136079C-A39C-4F8F-86A9-A7D2A00C112A}"/>
+                <a16:creationId xmlns:a16="http://schemas.microsoft.com/office/drawing/2014/main" id="{892B0578-EEFD-4D0C-8777-0E194A2F1663}"/>
               </a:ext>
             </a:extLst>
           </p:cNvPr>
@@ -1594,7 +1594,7 @@
           <p:cNvPr id="3" name="">
             <a:extLst xmlns:a="http://schemas.openxmlformats.org/drawingml/2006/main">
               <a:ext uri="{FF2B5EF4-FFF2-40B4-BE49-F238E27FC236}">
-                <a16:creationId xmlns:a16="http://schemas.microsoft.com/office/drawing/2014/main" id="{A6149B48-1CDB-476B-A06B-DD1F746BB412}"/>
+                <a16:creationId xmlns:a16="http://schemas.microsoft.com/office/drawing/2014/main" id="{383FB2B9-A9EB-4C70-861C-966382B6F876}"/>
               </a:ext>
             </a:extLst>
           </p:cNvPr>
@@ -1658,7 +1658,7 @@
           <p:cNvPr id="4" name="">
             <a:extLst xmlns:a="http://schemas.openxmlformats.org/drawingml/2006/main">
               <a:ext uri="{FF2B5EF4-FFF2-40B4-BE49-F238E27FC236}">
-                <a16:creationId xmlns:a16="http://schemas.microsoft.com/office/drawing/2014/main" id="{F0FFD829-608E-40AB-948F-CAB50F6906D1}"/>
+                <a16:creationId xmlns:a16="http://schemas.microsoft.com/office/drawing/2014/main" id="{6FEE5942-8C15-49FF-8CDB-7E9589768733}"/>
               </a:ext>
             </a:extLst>
           </p:cNvPr>
@@ -1722,7 +1722,7 @@
           <p:cNvPr id="5" name="">
             <a:extLst xmlns:a="http://schemas.openxmlformats.org/drawingml/2006/main">
               <a:ext uri="{FF2B5EF4-FFF2-40B4-BE49-F238E27FC236}">
-                <a16:creationId xmlns:a16="http://schemas.microsoft.com/office/drawing/2014/main" id="{65218914-578C-4151-9D72-84ECABFE9CDA}"/>
+                <a16:creationId xmlns:a16="http://schemas.microsoft.com/office/drawing/2014/main" id="{68635897-CF92-446A-9306-CC1D5126D8CF}"/>
               </a:ext>
             </a:extLst>
           </p:cNvPr>
@@ -1790,10 +1790,10 @@
           <p:nvPr/>
         </p:nvPicPr>
         <p:blipFill>
-          <a:blip xmlns:r="http://schemas.openxmlformats.org/officeDocument/2006/relationships" xmlns:a="http://schemas.openxmlformats.org/drawingml/2006/main" r:embed="R945c63a0805a4cac">
+          <a:blip xmlns:r="http://schemas.openxmlformats.org/officeDocument/2006/relationships" xmlns:a="http://schemas.openxmlformats.org/drawingml/2006/main" r:embed="R19c3bb76ca864fe5">
             <a:extLst>
               <a:ext uri="{96DAC541-7B7A-43D3-8B79-37D633B846F1}">
-                <asvg:svgBlip xmlns:asvg="http://schemas.microsoft.com/office/drawing/2016/SVG/main" r:embed="R3aa480e88fd74bb2"/>
+                <asvg:svgBlip xmlns:asvg="http://schemas.microsoft.com/office/drawing/2016/SVG/main" r:embed="R2ae462350bfb4bc7"/>
               </a:ext>
             </a:extLst>
           </a:blip>
@@ -1814,7 +1814,7 @@
           <p:cNvPr id="7" name="">
             <a:extLst xmlns:a="http://schemas.openxmlformats.org/drawingml/2006/main">
               <a:ext uri="{FF2B5EF4-FFF2-40B4-BE49-F238E27FC236}">
-                <a16:creationId xmlns:a16="http://schemas.microsoft.com/office/drawing/2014/main" id="{C7A5AE45-FBC0-4367-9859-DDD677925581}"/>
+                <a16:creationId xmlns:a16="http://schemas.microsoft.com/office/drawing/2014/main" id="{B7E9187A-47F8-4DF6-938E-65217C323262}"/>
               </a:ext>
             </a:extLst>
           </p:cNvPr>
@@ -1847,7 +1847,7 @@
           <p:cNvPr id="8" name="">
             <a:extLst xmlns:a="http://schemas.openxmlformats.org/drawingml/2006/main">
               <a:ext uri="{FF2B5EF4-FFF2-40B4-BE49-F238E27FC236}">
-                <a16:creationId xmlns:a16="http://schemas.microsoft.com/office/drawing/2014/main" id="{CB635D99-6245-45FB-A7EB-B36140B1F7A7}"/>
+                <a16:creationId xmlns:a16="http://schemas.microsoft.com/office/drawing/2014/main" id="{4252258D-BB73-4A89-93F2-08877B7C274B}"/>
               </a:ext>
             </a:extLst>
           </p:cNvPr>
@@ -1882,7 +1882,7 @@
           <p:cNvPr id="9" name="">
             <a:extLst xmlns:a="http://schemas.openxmlformats.org/drawingml/2006/main">
               <a:ext uri="{FF2B5EF4-FFF2-40B4-BE49-F238E27FC236}">
-                <a16:creationId xmlns:a16="http://schemas.microsoft.com/office/drawing/2014/main" id="{DC3A551F-35E8-4A05-A8A4-D60D4461B3D4}"/>
+                <a16:creationId xmlns:a16="http://schemas.microsoft.com/office/drawing/2014/main" id="{18D6B14B-1AD6-49FB-AE04-36B5D0D1CCC7}"/>
               </a:ext>
             </a:extLst>
           </p:cNvPr>
@@ -1946,7 +1946,7 @@
           <p:cNvPr id="10" name="">
             <a:extLst xmlns:a="http://schemas.openxmlformats.org/drawingml/2006/main">
               <a:ext uri="{FF2B5EF4-FFF2-40B4-BE49-F238E27FC236}">
-                <a16:creationId xmlns:a16="http://schemas.microsoft.com/office/drawing/2014/main" id="{E0D95B32-0AEB-4382-A1C3-95B13CA17F6A}"/>
+                <a16:creationId xmlns:a16="http://schemas.microsoft.com/office/drawing/2014/main" id="{EA542BBF-3732-40FA-B286-584243ECBB5C}"/>
               </a:ext>
             </a:extLst>
           </p:cNvPr>
@@ -2010,7 +2010,7 @@
           <p:cNvPr id="11" name="">
             <a:extLst xmlns:a="http://schemas.openxmlformats.org/drawingml/2006/main">
               <a:ext uri="{FF2B5EF4-FFF2-40B4-BE49-F238E27FC236}">
-                <a16:creationId xmlns:a16="http://schemas.microsoft.com/office/drawing/2014/main" id="{39817CAA-6529-4987-B39B-BFF69BD2467C}"/>
+                <a16:creationId xmlns:a16="http://schemas.microsoft.com/office/drawing/2014/main" id="{E9749E85-E7B8-4C61-B431-D6514AB8DA4D}"/>
               </a:ext>
             </a:extLst>
           </p:cNvPr>
@@ -2043,7 +2043,7 @@
           <p:cNvPr id="12" name="">
             <a:extLst xmlns:a="http://schemas.openxmlformats.org/drawingml/2006/main">
               <a:ext uri="{FF2B5EF4-FFF2-40B4-BE49-F238E27FC236}">
-                <a16:creationId xmlns:a16="http://schemas.microsoft.com/office/drawing/2014/main" id="{96FEA82D-B3FC-408A-9945-0F37CE58C133}"/>
+                <a16:creationId xmlns:a16="http://schemas.microsoft.com/office/drawing/2014/main" id="{605AE077-68B2-48B5-AFC4-715CCE947DD7}"/>
               </a:ext>
             </a:extLst>
           </p:cNvPr>
@@ -2078,7 +2078,7 @@
           <p:cNvPr id="13" name="">
             <a:extLst xmlns:a="http://schemas.openxmlformats.org/drawingml/2006/main">
               <a:ext uri="{FF2B5EF4-FFF2-40B4-BE49-F238E27FC236}">
-                <a16:creationId xmlns:a16="http://schemas.microsoft.com/office/drawing/2014/main" id="{9E399514-0C17-446F-AC89-0A7A395DA95D}"/>
+                <a16:creationId xmlns:a16="http://schemas.microsoft.com/office/drawing/2014/main" id="{D08ADE04-6054-4386-A6AA-CB70A5A4307A}"/>
               </a:ext>
             </a:extLst>
           </p:cNvPr>
@@ -2142,7 +2142,7 @@
           <p:cNvPr id="14" name="">
             <a:extLst xmlns:a="http://schemas.openxmlformats.org/drawingml/2006/main">
               <a:ext uri="{FF2B5EF4-FFF2-40B4-BE49-F238E27FC236}">
-                <a16:creationId xmlns:a16="http://schemas.microsoft.com/office/drawing/2014/main" id="{396835F2-F3C7-49FA-B2E8-64F75048DDB2}"/>
+                <a16:creationId xmlns:a16="http://schemas.microsoft.com/office/drawing/2014/main" id="{1571C097-054D-4F76-9812-6E5E9BE83FCA}"/>
               </a:ext>
             </a:extLst>
           </p:cNvPr>
@@ -2206,7 +2206,7 @@
           <p:cNvPr id="15" name="">
             <a:extLst xmlns:a="http://schemas.openxmlformats.org/drawingml/2006/main">
               <a:ext uri="{FF2B5EF4-FFF2-40B4-BE49-F238E27FC236}">
-                <a16:creationId xmlns:a16="http://schemas.microsoft.com/office/drawing/2014/main" id="{409C5EF9-B343-49C7-AE0F-1E305E48768B}"/>
+                <a16:creationId xmlns:a16="http://schemas.microsoft.com/office/drawing/2014/main" id="{49CFABB2-EC87-42CD-B1E5-2D3311FC8403}"/>
               </a:ext>
             </a:extLst>
           </p:cNvPr>
@@ -2268,7 +2268,7 @@
     </p:spTree>
     <p:extLst>
       <p:ext uri="{BB962C8B-B14F-4D97-AF65-F5344CB8AC3E}">
-        <p14:creationId xmlns:p14="http://schemas.microsoft.com/office/powerpoint/2010/main" val="1362523909"/>
+        <p14:creationId xmlns:p14="http://schemas.microsoft.com/office/powerpoint/2010/main" val="1012386650"/>
       </p:ext>
     </p:extLst>
   </p:cSld>
@@ -2292,7 +2292,7 @@
           <p:cNvPr id="1" name="">
             <a:extLst xmlns:a="http://schemas.openxmlformats.org/drawingml/2006/main">
               <a:ext uri="{FF2B5EF4-FFF2-40B4-BE49-F238E27FC236}">
-                <a16:creationId xmlns:a16="http://schemas.microsoft.com/office/drawing/2014/main" id="{1A8CF31F-948D-4FE5-92B9-252457E04390}"/>
+                <a16:creationId xmlns:a16="http://schemas.microsoft.com/office/drawing/2014/main" id="{BEB11EA6-2485-4A71-90C8-D5DE4564AEE1}"/>
               </a:ext>
             </a:extLst>
           </p:cNvPr>
@@ -2327,7 +2327,7 @@
           <p:cNvPr id="2" name="">
             <a:extLst xmlns:a="http://schemas.openxmlformats.org/drawingml/2006/main">
               <a:ext uri="{FF2B5EF4-FFF2-40B4-BE49-F238E27FC236}">
-                <a16:creationId xmlns:a16="http://schemas.microsoft.com/office/drawing/2014/main" id="{871207E5-DAD9-4D6C-AD96-B0834118D1E7}"/>
+                <a16:creationId xmlns:a16="http://schemas.microsoft.com/office/drawing/2014/main" id="{FCEA8372-472B-4557-BCDD-967DFC5548CB}"/>
               </a:ext>
             </a:extLst>
           </p:cNvPr>
@@ -2362,7 +2362,7 @@
           <p:cNvPr id="3" name="">
             <a:extLst xmlns:a="http://schemas.openxmlformats.org/drawingml/2006/main">
               <a:ext uri="{FF2B5EF4-FFF2-40B4-BE49-F238E27FC236}">
-                <a16:creationId xmlns:a16="http://schemas.microsoft.com/office/drawing/2014/main" id="{1E225D3D-6A67-4234-BCFD-578FF2F26622}"/>
+                <a16:creationId xmlns:a16="http://schemas.microsoft.com/office/drawing/2014/main" id="{2D61127D-1108-4EA8-90BE-43E4BF26A008}"/>
               </a:ext>
             </a:extLst>
           </p:cNvPr>
@@ -2426,7 +2426,7 @@
           <p:cNvPr id="4" name="">
             <a:extLst xmlns:a="http://schemas.openxmlformats.org/drawingml/2006/main">
               <a:ext uri="{FF2B5EF4-FFF2-40B4-BE49-F238E27FC236}">
-                <a16:creationId xmlns:a16="http://schemas.microsoft.com/office/drawing/2014/main" id="{E4CF13AA-3155-4834-ACE3-88799FBE9A79}"/>
+                <a16:creationId xmlns:a16="http://schemas.microsoft.com/office/drawing/2014/main" id="{9E1A3B84-DE1F-4776-ADE5-AF4DCA082420}"/>
               </a:ext>
             </a:extLst>
           </p:cNvPr>
@@ -2490,7 +2490,7 @@
           <p:cNvPr id="5" name="">
             <a:extLst xmlns:a="http://schemas.openxmlformats.org/drawingml/2006/main">
               <a:ext uri="{FF2B5EF4-FFF2-40B4-BE49-F238E27FC236}">
-                <a16:creationId xmlns:a16="http://schemas.microsoft.com/office/drawing/2014/main" id="{01023927-31CB-4094-A719-A0635762DC34}"/>
+                <a16:creationId xmlns:a16="http://schemas.microsoft.com/office/drawing/2014/main" id="{707F29C2-F835-4010-92BA-C09AE69B4AA9}"/>
               </a:ext>
             </a:extLst>
           </p:cNvPr>
@@ -2558,7 +2558,7 @@
           <p:nvPr/>
         </p:nvPicPr>
         <p:blipFill>
-          <a:blip xmlns:r="http://schemas.openxmlformats.org/officeDocument/2006/relationships" xmlns:a="http://schemas.openxmlformats.org/drawingml/2006/main" r:embed="Rb3c2564201ef4265"/>
+          <a:blip xmlns:r="http://schemas.openxmlformats.org/officeDocument/2006/relationships" xmlns:a="http://schemas.openxmlformats.org/drawingml/2006/main" r:embed="Rcf7913c49a4b4e4f"/>
           <a:stretch xmlns:a="http://schemas.openxmlformats.org/drawingml/2006/main"/>
         </p:blipFill>
         <p:spPr>
@@ -2576,7 +2576,7 @@
           <p:cNvPr id="7" name="">
             <a:extLst xmlns:a="http://schemas.openxmlformats.org/drawingml/2006/main">
               <a:ext uri="{FF2B5EF4-FFF2-40B4-BE49-F238E27FC236}">
-                <a16:creationId xmlns:a16="http://schemas.microsoft.com/office/drawing/2014/main" id="{FDB97181-4CBD-4EA6-BD41-D4A1AFC55658}"/>
+                <a16:creationId xmlns:a16="http://schemas.microsoft.com/office/drawing/2014/main" id="{FC49514E-9930-499E-B171-0A09C1CE98B4}"/>
               </a:ext>
             </a:extLst>
           </p:cNvPr>
@@ -2609,7 +2609,7 @@
           <p:cNvPr id="8" name="">
             <a:extLst xmlns:a="http://schemas.openxmlformats.org/drawingml/2006/main">
               <a:ext uri="{FF2B5EF4-FFF2-40B4-BE49-F238E27FC236}">
-                <a16:creationId xmlns:a16="http://schemas.microsoft.com/office/drawing/2014/main" id="{21D26F7C-415A-44DC-9A96-B33E64BBD2D0}"/>
+                <a16:creationId xmlns:a16="http://schemas.microsoft.com/office/drawing/2014/main" id="{A5140A83-5D9C-4B61-8ECF-0D22D906C3FA}"/>
               </a:ext>
             </a:extLst>
           </p:cNvPr>
@@ -2644,7 +2644,7 @@
           <p:cNvPr id="9" name="">
             <a:extLst xmlns:a="http://schemas.openxmlformats.org/drawingml/2006/main">
               <a:ext uri="{FF2B5EF4-FFF2-40B4-BE49-F238E27FC236}">
-                <a16:creationId xmlns:a16="http://schemas.microsoft.com/office/drawing/2014/main" id="{8DBF3AB7-E69A-4102-A0EA-CD91F644CBB8}"/>
+                <a16:creationId xmlns:a16="http://schemas.microsoft.com/office/drawing/2014/main" id="{C668057B-1019-4C1B-A9B6-0A09CEDD03AC}"/>
               </a:ext>
             </a:extLst>
           </p:cNvPr>
@@ -2708,7 +2708,7 @@
           <p:cNvPr id="10" name="">
             <a:extLst xmlns:a="http://schemas.openxmlformats.org/drawingml/2006/main">
               <a:ext uri="{FF2B5EF4-FFF2-40B4-BE49-F238E27FC236}">
-                <a16:creationId xmlns:a16="http://schemas.microsoft.com/office/drawing/2014/main" id="{2CE5E9DD-7CF7-4682-888C-C5BE3A96E427}"/>
+                <a16:creationId xmlns:a16="http://schemas.microsoft.com/office/drawing/2014/main" id="{0DFC9B59-09C8-46F0-B411-4E3A6583B262}"/>
               </a:ext>
             </a:extLst>
           </p:cNvPr>
@@ -2772,7 +2772,7 @@
           <p:cNvPr id="11" name="">
             <a:extLst xmlns:a="http://schemas.openxmlformats.org/drawingml/2006/main">
               <a:ext uri="{FF2B5EF4-FFF2-40B4-BE49-F238E27FC236}">
-                <a16:creationId xmlns:a16="http://schemas.microsoft.com/office/drawing/2014/main" id="{F52AD02D-5A84-4B8C-9731-E04E8C593CB1}"/>
+                <a16:creationId xmlns:a16="http://schemas.microsoft.com/office/drawing/2014/main" id="{041E6454-C55A-41B3-A9FC-2D4193A7B7E4}"/>
               </a:ext>
             </a:extLst>
           </p:cNvPr>
@@ -2805,7 +2805,7 @@
           <p:cNvPr id="12" name="">
             <a:extLst xmlns:a="http://schemas.openxmlformats.org/drawingml/2006/main">
               <a:ext uri="{FF2B5EF4-FFF2-40B4-BE49-F238E27FC236}">
-                <a16:creationId xmlns:a16="http://schemas.microsoft.com/office/drawing/2014/main" id="{7221354A-35BA-4498-87AB-8CD3645F4E95}"/>
+                <a16:creationId xmlns:a16="http://schemas.microsoft.com/office/drawing/2014/main" id="{E3FD82F3-F1EE-49E5-96E5-816479CE9FEA}"/>
               </a:ext>
             </a:extLst>
           </p:cNvPr>
@@ -2840,7 +2840,7 @@
           <p:cNvPr id="13" name="">
             <a:extLst xmlns:a="http://schemas.openxmlformats.org/drawingml/2006/main">
               <a:ext uri="{FF2B5EF4-FFF2-40B4-BE49-F238E27FC236}">
-                <a16:creationId xmlns:a16="http://schemas.microsoft.com/office/drawing/2014/main" id="{ACB76773-7C64-451D-A9F2-D4424F0ED290}"/>
+                <a16:creationId xmlns:a16="http://schemas.microsoft.com/office/drawing/2014/main" id="{1BD9E7B3-1D0C-4742-BDD6-9D37DF977B9F}"/>
               </a:ext>
             </a:extLst>
           </p:cNvPr>
@@ -2904,7 +2904,7 @@
           <p:cNvPr id="14" name="">
             <a:extLst xmlns:a="http://schemas.openxmlformats.org/drawingml/2006/main">
               <a:ext uri="{FF2B5EF4-FFF2-40B4-BE49-F238E27FC236}">
-                <a16:creationId xmlns:a16="http://schemas.microsoft.com/office/drawing/2014/main" id="{D9D5A1AE-EEE2-4B6D-8984-C92DC92C5165}"/>
+                <a16:creationId xmlns:a16="http://schemas.microsoft.com/office/drawing/2014/main" id="{192FBDE6-9237-4A71-8E5A-3FB9E17FE447}"/>
               </a:ext>
             </a:extLst>
           </p:cNvPr>
@@ -2968,7 +2968,7 @@
           <p:cNvPr id="15" name="">
             <a:extLst xmlns:a="http://schemas.openxmlformats.org/drawingml/2006/main">
               <a:ext uri="{FF2B5EF4-FFF2-40B4-BE49-F238E27FC236}">
-                <a16:creationId xmlns:a16="http://schemas.microsoft.com/office/drawing/2014/main" id="{96F38F98-8D05-425C-84E8-C0C19FAC8F69}"/>
+                <a16:creationId xmlns:a16="http://schemas.microsoft.com/office/drawing/2014/main" id="{D805599F-406C-4273-9640-3A44E50BAF23}"/>
               </a:ext>
             </a:extLst>
           </p:cNvPr>
@@ -3001,7 +3001,7 @@
           <p:cNvPr id="16" name="">
             <a:extLst xmlns:a="http://schemas.openxmlformats.org/drawingml/2006/main">
               <a:ext uri="{FF2B5EF4-FFF2-40B4-BE49-F238E27FC236}">
-                <a16:creationId xmlns:a16="http://schemas.microsoft.com/office/drawing/2014/main" id="{3A4BBEB2-5572-49D3-B6CC-A36D8DA73F4C}"/>
+                <a16:creationId xmlns:a16="http://schemas.microsoft.com/office/drawing/2014/main" id="{088F928A-2CB7-49C6-A129-9E2D28C7FEC9}"/>
               </a:ext>
             </a:extLst>
           </p:cNvPr>
@@ -3036,7 +3036,7 @@
           <p:cNvPr id="17" name="">
             <a:extLst xmlns:a="http://schemas.openxmlformats.org/drawingml/2006/main">
               <a:ext uri="{FF2B5EF4-FFF2-40B4-BE49-F238E27FC236}">
-                <a16:creationId xmlns:a16="http://schemas.microsoft.com/office/drawing/2014/main" id="{594952DC-B614-4D94-9C19-5785DF0E568F}"/>
+                <a16:creationId xmlns:a16="http://schemas.microsoft.com/office/drawing/2014/main" id="{622F5739-61BE-48D5-9C94-513004C10223}"/>
               </a:ext>
             </a:extLst>
           </p:cNvPr>
@@ -3100,7 +3100,7 @@
           <p:cNvPr id="18" name="">
             <a:extLst xmlns:a="http://schemas.openxmlformats.org/drawingml/2006/main">
               <a:ext uri="{FF2B5EF4-FFF2-40B4-BE49-F238E27FC236}">
-                <a16:creationId xmlns:a16="http://schemas.microsoft.com/office/drawing/2014/main" id="{7E4BD7FA-EF1E-40C6-BADE-363CC5C99A84}"/>
+                <a16:creationId xmlns:a16="http://schemas.microsoft.com/office/drawing/2014/main" id="{26B3FBA1-5159-40A9-BF1A-F2A265AD7B28}"/>
               </a:ext>
             </a:extLst>
           </p:cNvPr>
@@ -3164,7 +3164,7 @@
           <p:cNvPr id="19" name="">
             <a:extLst xmlns:a="http://schemas.openxmlformats.org/drawingml/2006/main">
               <a:ext uri="{FF2B5EF4-FFF2-40B4-BE49-F238E27FC236}">
-                <a16:creationId xmlns:a16="http://schemas.microsoft.com/office/drawing/2014/main" id="{99C2CF84-05B1-4824-93A8-A5A894F7D73B}"/>
+                <a16:creationId xmlns:a16="http://schemas.microsoft.com/office/drawing/2014/main" id="{DA845F5D-9914-4A80-B1F4-0B41D7604B3E}"/>
               </a:ext>
             </a:extLst>
           </p:cNvPr>
@@ -3226,7 +3226,7 @@
     </p:spTree>
     <p:extLst>
       <p:ext uri="{BB962C8B-B14F-4D97-AF65-F5344CB8AC3E}">
-        <p14:creationId xmlns:p14="http://schemas.microsoft.com/office/powerpoint/2010/main" val="1361844959"/>
+        <p14:creationId xmlns:p14="http://schemas.microsoft.com/office/powerpoint/2010/main" val="2011423787"/>
       </p:ext>
     </p:extLst>
   </p:cSld>
@@ -3250,7 +3250,7 @@
           <p:cNvPr id="1" name="">
             <a:extLst xmlns:a="http://schemas.openxmlformats.org/drawingml/2006/main">
               <a:ext uri="{FF2B5EF4-FFF2-40B4-BE49-F238E27FC236}">
-                <a16:creationId xmlns:a16="http://schemas.microsoft.com/office/drawing/2014/main" id="{43C7194E-582C-4C11-9480-5C4A0E8879ED}"/>
+                <a16:creationId xmlns:a16="http://schemas.microsoft.com/office/drawing/2014/main" id="{3DD9DB2D-7F97-46DE-A77C-6598F30FA813}"/>
               </a:ext>
             </a:extLst>
           </p:cNvPr>
@@ -3285,7 +3285,7 @@
           <p:cNvPr id="2" name="">
             <a:extLst xmlns:a="http://schemas.openxmlformats.org/drawingml/2006/main">
               <a:ext uri="{FF2B5EF4-FFF2-40B4-BE49-F238E27FC236}">
-                <a16:creationId xmlns:a16="http://schemas.microsoft.com/office/drawing/2014/main" id="{B34B6C81-1564-4C0C-9A1B-A72BA980BC7A}"/>
+                <a16:creationId xmlns:a16="http://schemas.microsoft.com/office/drawing/2014/main" id="{70DE9407-0480-4506-9BC9-EF3A74E9721B}"/>
               </a:ext>
             </a:extLst>
           </p:cNvPr>
@@ -3320,7 +3320,7 @@
           <p:cNvPr id="3" name="">
             <a:extLst xmlns:a="http://schemas.openxmlformats.org/drawingml/2006/main">
               <a:ext uri="{FF2B5EF4-FFF2-40B4-BE49-F238E27FC236}">
-                <a16:creationId xmlns:a16="http://schemas.microsoft.com/office/drawing/2014/main" id="{5ABD5897-5583-4435-9BD2-A2ACA89C9271}"/>
+                <a16:creationId xmlns:a16="http://schemas.microsoft.com/office/drawing/2014/main" id="{BAC75B6D-9BC7-465A-96EE-5EBF5E780178}"/>
               </a:ext>
             </a:extLst>
           </p:cNvPr>
@@ -3384,7 +3384,7 @@
           <p:cNvPr id="4" name="">
             <a:extLst xmlns:a="http://schemas.openxmlformats.org/drawingml/2006/main">
               <a:ext uri="{FF2B5EF4-FFF2-40B4-BE49-F238E27FC236}">
-                <a16:creationId xmlns:a16="http://schemas.microsoft.com/office/drawing/2014/main" id="{13D71D06-E280-494C-B131-65204012DA98}"/>
+                <a16:creationId xmlns:a16="http://schemas.microsoft.com/office/drawing/2014/main" id="{75D439A0-51D0-4699-8F16-49E8F5D65086}"/>
               </a:ext>
             </a:extLst>
           </p:cNvPr>
@@ -3448,7 +3448,7 @@
           <p:cNvPr id="5" name="">
             <a:extLst xmlns:a="http://schemas.openxmlformats.org/drawingml/2006/main">
               <a:ext uri="{FF2B5EF4-FFF2-40B4-BE49-F238E27FC236}">
-                <a16:creationId xmlns:a16="http://schemas.microsoft.com/office/drawing/2014/main" id="{1DA86DB7-A167-4D90-BA99-97585623A3F2}"/>
+                <a16:creationId xmlns:a16="http://schemas.microsoft.com/office/drawing/2014/main" id="{3A44CF86-145D-44AB-8472-1C0495E2DC08}"/>
               </a:ext>
             </a:extLst>
           </p:cNvPr>
@@ -3516,7 +3516,7 @@
           <p:nvPr/>
         </p:nvPicPr>
         <p:blipFill>
-          <a:blip xmlns:r="http://schemas.openxmlformats.org/officeDocument/2006/relationships" xmlns:a="http://schemas.openxmlformats.org/drawingml/2006/main" r:embed="Raa52476874d54307"/>
+          <a:blip xmlns:r="http://schemas.openxmlformats.org/officeDocument/2006/relationships" xmlns:a="http://schemas.openxmlformats.org/drawingml/2006/main" r:embed="R099a185fd6c749d9"/>
           <a:stretch xmlns:a="http://schemas.openxmlformats.org/drawingml/2006/main"/>
         </p:blipFill>
         <p:spPr>
@@ -3534,7 +3534,7 @@
           <p:cNvPr id="7" name="">
             <a:extLst xmlns:a="http://schemas.openxmlformats.org/drawingml/2006/main">
               <a:ext uri="{FF2B5EF4-FFF2-40B4-BE49-F238E27FC236}">
-                <a16:creationId xmlns:a16="http://schemas.microsoft.com/office/drawing/2014/main" id="{1678CF09-1A81-4A14-B349-B9E9E207A760}"/>
+                <a16:creationId xmlns:a16="http://schemas.microsoft.com/office/drawing/2014/main" id="{1486A66D-F7BE-4209-9F7E-E2113CD4CC04}"/>
               </a:ext>
             </a:extLst>
           </p:cNvPr>
@@ -3567,7 +3567,7 @@
           <p:cNvPr id="8" name="">
             <a:extLst xmlns:a="http://schemas.openxmlformats.org/drawingml/2006/main">
               <a:ext uri="{FF2B5EF4-FFF2-40B4-BE49-F238E27FC236}">
-                <a16:creationId xmlns:a16="http://schemas.microsoft.com/office/drawing/2014/main" id="{7F2267D4-3814-4311-89A3-21E9B1CE4E50}"/>
+                <a16:creationId xmlns:a16="http://schemas.microsoft.com/office/drawing/2014/main" id="{3D030CD9-614C-41D2-B172-7915AC013348}"/>
               </a:ext>
             </a:extLst>
           </p:cNvPr>
@@ -3602,7 +3602,7 @@
           <p:cNvPr id="9" name="">
             <a:extLst xmlns:a="http://schemas.openxmlformats.org/drawingml/2006/main">
               <a:ext uri="{FF2B5EF4-FFF2-40B4-BE49-F238E27FC236}">
-                <a16:creationId xmlns:a16="http://schemas.microsoft.com/office/drawing/2014/main" id="{73D41B0D-BD3E-4D77-8C86-059334670BCB}"/>
+                <a16:creationId xmlns:a16="http://schemas.microsoft.com/office/drawing/2014/main" id="{866A06C9-9431-459E-AB35-EB074FE5C215}"/>
               </a:ext>
             </a:extLst>
           </p:cNvPr>
@@ -3666,7 +3666,7 @@
           <p:cNvPr id="10" name="">
             <a:extLst xmlns:a="http://schemas.openxmlformats.org/drawingml/2006/main">
               <a:ext uri="{FF2B5EF4-FFF2-40B4-BE49-F238E27FC236}">
-                <a16:creationId xmlns:a16="http://schemas.microsoft.com/office/drawing/2014/main" id="{A7340184-12BD-4370-B47B-2DB5B462A970}"/>
+                <a16:creationId xmlns:a16="http://schemas.microsoft.com/office/drawing/2014/main" id="{00B4E9B4-0897-43B0-A22D-9B1323ABC4BA}"/>
               </a:ext>
             </a:extLst>
           </p:cNvPr>
@@ -3730,7 +3730,7 @@
           <p:cNvPr id="11" name="">
             <a:extLst xmlns:a="http://schemas.openxmlformats.org/drawingml/2006/main">
               <a:ext uri="{FF2B5EF4-FFF2-40B4-BE49-F238E27FC236}">
-                <a16:creationId xmlns:a16="http://schemas.microsoft.com/office/drawing/2014/main" id="{CFD8BF99-EB84-4809-A0AC-90207BED7205}"/>
+                <a16:creationId xmlns:a16="http://schemas.microsoft.com/office/drawing/2014/main" id="{E9AC63AE-0025-473A-A021-95A37B50255D}"/>
               </a:ext>
             </a:extLst>
           </p:cNvPr>
@@ -3763,7 +3763,7 @@
           <p:cNvPr id="12" name="">
             <a:extLst xmlns:a="http://schemas.openxmlformats.org/drawingml/2006/main">
               <a:ext uri="{FF2B5EF4-FFF2-40B4-BE49-F238E27FC236}">
-                <a16:creationId xmlns:a16="http://schemas.microsoft.com/office/drawing/2014/main" id="{29CD2A9A-F211-4CED-AF61-B5D1E103D074}"/>
+                <a16:creationId xmlns:a16="http://schemas.microsoft.com/office/drawing/2014/main" id="{3AFB9E53-037B-404F-80A9-650DFDEF5A13}"/>
               </a:ext>
             </a:extLst>
           </p:cNvPr>
@@ -3798,7 +3798,7 @@
           <p:cNvPr id="13" name="">
             <a:extLst xmlns:a="http://schemas.openxmlformats.org/drawingml/2006/main">
               <a:ext uri="{FF2B5EF4-FFF2-40B4-BE49-F238E27FC236}">
-                <a16:creationId xmlns:a16="http://schemas.microsoft.com/office/drawing/2014/main" id="{3C9044C4-B873-4390-A3AB-DF6495FB5CA7}"/>
+                <a16:creationId xmlns:a16="http://schemas.microsoft.com/office/drawing/2014/main" id="{EC706DFD-3036-4118-8C13-E1AB668B0A8A}"/>
               </a:ext>
             </a:extLst>
           </p:cNvPr>
@@ -3862,7 +3862,7 @@
           <p:cNvPr id="14" name="">
             <a:extLst xmlns:a="http://schemas.openxmlformats.org/drawingml/2006/main">
               <a:ext uri="{FF2B5EF4-FFF2-40B4-BE49-F238E27FC236}">
-                <a16:creationId xmlns:a16="http://schemas.microsoft.com/office/drawing/2014/main" id="{B652AE92-76C9-4391-A1AF-F9C75296B4E8}"/>
+                <a16:creationId xmlns:a16="http://schemas.microsoft.com/office/drawing/2014/main" id="{A1098E34-B961-4AA5-8EA2-A6615352F801}"/>
               </a:ext>
             </a:extLst>
           </p:cNvPr>
@@ -3926,7 +3926,7 @@
           <p:cNvPr id="15" name="">
             <a:extLst xmlns:a="http://schemas.openxmlformats.org/drawingml/2006/main">
               <a:ext uri="{FF2B5EF4-FFF2-40B4-BE49-F238E27FC236}">
-                <a16:creationId xmlns:a16="http://schemas.microsoft.com/office/drawing/2014/main" id="{A375D6A8-7FB1-4D1B-A9F8-15A78DDC2174}"/>
+                <a16:creationId xmlns:a16="http://schemas.microsoft.com/office/drawing/2014/main" id="{07E0F389-854E-451F-BA42-54B3F75F8C8A}"/>
               </a:ext>
             </a:extLst>
           </p:cNvPr>
@@ -3959,7 +3959,7 @@
           <p:cNvPr id="16" name="">
             <a:extLst xmlns:a="http://schemas.openxmlformats.org/drawingml/2006/main">
               <a:ext uri="{FF2B5EF4-FFF2-40B4-BE49-F238E27FC236}">
-                <a16:creationId xmlns:a16="http://schemas.microsoft.com/office/drawing/2014/main" id="{A54F15F9-D383-42C8-830A-DAD572C46F7A}"/>
+                <a16:creationId xmlns:a16="http://schemas.microsoft.com/office/drawing/2014/main" id="{AAB3E4C2-324E-4A47-9B13-BD3AAE67C2B7}"/>
               </a:ext>
             </a:extLst>
           </p:cNvPr>
@@ -3994,7 +3994,7 @@
           <p:cNvPr id="17" name="">
             <a:extLst xmlns:a="http://schemas.openxmlformats.org/drawingml/2006/main">
               <a:ext uri="{FF2B5EF4-FFF2-40B4-BE49-F238E27FC236}">
-                <a16:creationId xmlns:a16="http://schemas.microsoft.com/office/drawing/2014/main" id="{9E0CDEBE-FD4B-4CC0-98D6-177A359FE05E}"/>
+                <a16:creationId xmlns:a16="http://schemas.microsoft.com/office/drawing/2014/main" id="{2420BDE6-5970-46D0-A151-39A6CC2706EB}"/>
               </a:ext>
             </a:extLst>
           </p:cNvPr>
@@ -4058,7 +4058,7 @@
           <p:cNvPr id="18" name="">
             <a:extLst xmlns:a="http://schemas.openxmlformats.org/drawingml/2006/main">
               <a:ext uri="{FF2B5EF4-FFF2-40B4-BE49-F238E27FC236}">
-                <a16:creationId xmlns:a16="http://schemas.microsoft.com/office/drawing/2014/main" id="{0FC19227-CB02-4799-A0B9-A3500A83A02D}"/>
+                <a16:creationId xmlns:a16="http://schemas.microsoft.com/office/drawing/2014/main" id="{2A9EC098-F69B-4FC0-805E-685EF0DFD0CC}"/>
               </a:ext>
             </a:extLst>
           </p:cNvPr>
@@ -4122,7 +4122,7 @@
           <p:cNvPr id="19" name="">
             <a:extLst xmlns:a="http://schemas.openxmlformats.org/drawingml/2006/main">
               <a:ext uri="{FF2B5EF4-FFF2-40B4-BE49-F238E27FC236}">
-                <a16:creationId xmlns:a16="http://schemas.microsoft.com/office/drawing/2014/main" id="{42DAEB5A-EF65-4A03-9270-1341DCC93401}"/>
+                <a16:creationId xmlns:a16="http://schemas.microsoft.com/office/drawing/2014/main" id="{B2FB41B5-2E4A-4C69-8019-F801FDACE3F1}"/>
               </a:ext>
             </a:extLst>
           </p:cNvPr>
@@ -4184,7 +4184,7 @@
     </p:spTree>
     <p:extLst>
       <p:ext uri="{BB962C8B-B14F-4D97-AF65-F5344CB8AC3E}">
-        <p14:creationId xmlns:p14="http://schemas.microsoft.com/office/powerpoint/2010/main" val="402551121"/>
+        <p14:creationId xmlns:p14="http://schemas.microsoft.com/office/powerpoint/2010/main" val="1320777240"/>
       </p:ext>
     </p:extLst>
   </p:cSld>
@@ -4208,7 +4208,7 @@
           <p:cNvPr id="1" name="">
             <a:extLst xmlns:a="http://schemas.openxmlformats.org/drawingml/2006/main">
               <a:ext uri="{FF2B5EF4-FFF2-40B4-BE49-F238E27FC236}">
-                <a16:creationId xmlns:a16="http://schemas.microsoft.com/office/drawing/2014/main" id="{F16B6680-029D-448A-B039-3D6C0F2B8E06}"/>
+                <a16:creationId xmlns:a16="http://schemas.microsoft.com/office/drawing/2014/main" id="{DEF99DFE-65EC-4C4F-BE41-8B989B2292A2}"/>
               </a:ext>
             </a:extLst>
           </p:cNvPr>
@@ -4243,7 +4243,7 @@
           <p:cNvPr id="2" name="">
             <a:extLst xmlns:a="http://schemas.openxmlformats.org/drawingml/2006/main">
               <a:ext uri="{FF2B5EF4-FFF2-40B4-BE49-F238E27FC236}">
-                <a16:creationId xmlns:a16="http://schemas.microsoft.com/office/drawing/2014/main" id="{4DA1BE94-E92D-45D4-A1E8-4DD2FB85F5C9}"/>
+                <a16:creationId xmlns:a16="http://schemas.microsoft.com/office/drawing/2014/main" id="{373288FA-C8C4-48C5-98A2-B87F4DF4C606}"/>
               </a:ext>
             </a:extLst>
           </p:cNvPr>
@@ -4278,7 +4278,7 @@
           <p:cNvPr id="3" name="">
             <a:extLst xmlns:a="http://schemas.openxmlformats.org/drawingml/2006/main">
               <a:ext uri="{FF2B5EF4-FFF2-40B4-BE49-F238E27FC236}">
-                <a16:creationId xmlns:a16="http://schemas.microsoft.com/office/drawing/2014/main" id="{572A01F8-49FD-46AA-A206-8AD1AFC77958}"/>
+                <a16:creationId xmlns:a16="http://schemas.microsoft.com/office/drawing/2014/main" id="{A0CF2219-251D-42BC-B223-7E705D72797F}"/>
               </a:ext>
             </a:extLst>
           </p:cNvPr>
@@ -4342,7 +4342,7 @@
           <p:cNvPr id="4" name="">
             <a:extLst xmlns:a="http://schemas.openxmlformats.org/drawingml/2006/main">
               <a:ext uri="{FF2B5EF4-FFF2-40B4-BE49-F238E27FC236}">
-                <a16:creationId xmlns:a16="http://schemas.microsoft.com/office/drawing/2014/main" id="{460621E4-C378-4E36-A346-178A3471CD19}"/>
+                <a16:creationId xmlns:a16="http://schemas.microsoft.com/office/drawing/2014/main" id="{C2230045-19B9-45E4-801B-699AFC3D100D}"/>
               </a:ext>
             </a:extLst>
           </p:cNvPr>
@@ -4401,86 +4401,22 @@
           </a:p>
         </p:txBody>
       </p:sp>
-      <p:sp>
-        <p:nvSpPr>
-          <p:cNvPr id="5" name="">
-            <a:extLst xmlns:a="http://schemas.openxmlformats.org/drawingml/2006/main">
-              <a:ext uri="{FF2B5EF4-FFF2-40B4-BE49-F238E27FC236}">
-                <a16:creationId xmlns:a16="http://schemas.microsoft.com/office/drawing/2014/main" id="{DEA02232-3AD8-497C-9495-90CDD9FC79B2}"/>
-              </a:ext>
-            </a:extLst>
-          </p:cNvPr>
-          <p:cNvSpPr>
-            <a:spLocks xmlns:a="http://schemas.openxmlformats.org/drawingml/2006/main" noGrp="1"/>
-          </p:cNvSpPr>
-          <p:nvPr/>
-        </p:nvSpPr>
-        <p:spPr>
-          <a:xfrm xmlns:a="http://schemas.openxmlformats.org/drawingml/2006/main">
-            <a:off x="552450" y="1428750"/>
-            <a:ext cx="7810500" cy="457200"/>
-          </a:xfrm>
-          <a:prstGeom xmlns:a="http://schemas.openxmlformats.org/drawingml/2006/main" prst="rect">
-            <a:avLst/>
-          </a:prstGeom>
-          <a:solidFill xmlns:a="http://schemas.openxmlformats.org/drawingml/2006/main">
-            <a:srgbClr val="000000">
-              <a:alpha val="0"/>
-            </a:srgbClr>
-          </a:solidFill>
-          <a:ln xmlns:a="http://schemas.openxmlformats.org/drawingml/2006/main" w="0">
-            <a:solidFill>
-              <a:srgbClr val="000000">
-                <a:alpha val="0"/>
-              </a:srgbClr>
-            </a:solidFill>
-            <a:prstDash val="solid"/>
-          </a:ln>
-        </p:spPr>
-        <p:txBody>
-          <a:bodyPr xmlns:a="http://schemas.openxmlformats.org/drawingml/2006/main" lIns="0" tIns="0" rIns="0" bIns="0" anchor="t"/>
-          <a:lstStyle xmlns:a="http://schemas.openxmlformats.org/drawingml/2006/main"/>
-          <a:p xmlns:a="http://schemas.openxmlformats.org/drawingml/2006/main">
-            <a:pPr algn="l">
-              <a:defRPr sz="1350" b="0">
-                <a:solidFill>
-                  <a:srgbClr val="64748B"/>
-                </a:solidFill>
-                <a:latin typeface="Aptos"/>
-                <a:ea typeface="Aptos"/>
-                <a:cs typeface="Aptos"/>
-              </a:defRPr>
-            </a:pPr>
-            <a:r>
-              <a:rPr sz="1350" b="0">
-                <a:solidFill>
-                  <a:srgbClr val="64748B"/>
-                </a:solidFill>
-                <a:latin typeface="Aptos"/>
-                <a:ea typeface="Aptos"/>
-                <a:cs typeface="Aptos"/>
-              </a:rPr>
-              <a:t>Layer-by-layer fabrication turns one 3D object into many 2D geometry tasks.</a:t>
-            </a:r>
-          </a:p>
-        </p:txBody>
-      </p:sp>
       <p:pic>
         <p:nvPicPr>
-          <p:cNvPr id="6" name=""/>
+          <p:cNvPr id="5" name=""/>
           <p:cNvPicPr>
             <a:picLocks xmlns:a="http://schemas.openxmlformats.org/drawingml/2006/main" noChangeAspect="1"/>
           </p:cNvPicPr>
           <p:nvPr/>
         </p:nvPicPr>
         <p:blipFill>
-          <a:blip xmlns:r="http://schemas.openxmlformats.org/officeDocument/2006/relationships" xmlns:a="http://schemas.openxmlformats.org/drawingml/2006/main" r:embed="R4be50e26ba534eaa"/>
+          <a:blip xmlns:r="http://schemas.openxmlformats.org/officeDocument/2006/relationships" xmlns:a="http://schemas.openxmlformats.org/drawingml/2006/main" r:embed="R35d11aac163c4bec"/>
           <a:stretch xmlns:a="http://schemas.openxmlformats.org/drawingml/2006/main"/>
         </p:blipFill>
         <p:spPr>
           <a:xfrm xmlns:a="http://schemas.openxmlformats.org/drawingml/2006/main">
-            <a:off x="1066800" y="1754641"/>
-            <a:ext cx="9810750" cy="3643993"/>
+            <a:off x="803763" y="1428750"/>
+            <a:ext cx="10565423" cy="3924300"/>
           </a:xfrm>
           <a:prstGeom xmlns:a="http://schemas.openxmlformats.org/drawingml/2006/main" prst="rect">
             <a:avLst/>
@@ -4489,32 +4425,67 @@
       </p:pic>
       <p:sp>
         <p:nvSpPr>
+          <p:cNvPr id="6" name="">
+            <a:extLst xmlns:a="http://schemas.openxmlformats.org/drawingml/2006/main">
+              <a:ext uri="{FF2B5EF4-FFF2-40B4-BE49-F238E27FC236}">
+                <a16:creationId xmlns:a16="http://schemas.microsoft.com/office/drawing/2014/main" id="{628C0892-2048-44F1-B9EA-37D529603B98}"/>
+              </a:ext>
+            </a:extLst>
+          </p:cNvPr>
+          <p:cNvSpPr>
+            <a:spLocks xmlns:a="http://schemas.openxmlformats.org/drawingml/2006/main" noGrp="1"/>
+          </p:cNvSpPr>
+          <p:nvPr/>
+        </p:nvSpPr>
+        <p:spPr>
+          <a:xfrm xmlns:a="http://schemas.openxmlformats.org/drawingml/2006/main">
+            <a:off x="1200150" y="5676900"/>
+            <a:ext cx="4476750" cy="647700"/>
+          </a:xfrm>
+          <a:prstGeom xmlns:a="http://schemas.openxmlformats.org/drawingml/2006/main" prst="rect">
+            <a:avLst/>
+          </a:prstGeom>
+          <a:solidFill xmlns:a="http://schemas.openxmlformats.org/drawingml/2006/main">
+            <a:srgbClr val="FFFFFF"/>
+          </a:solidFill>
+          <a:ln xmlns:a="http://schemas.openxmlformats.org/drawingml/2006/main" w="9525">
+            <a:solidFill>
+              <a:srgbClr val="DBE4F0"/>
+            </a:solidFill>
+            <a:prstDash val="solid"/>
+          </a:ln>
+        </p:spPr>
+      </p:sp>
+      <p:sp>
+        <p:nvSpPr>
           <p:cNvPr id="7" name="">
             <a:extLst xmlns:a="http://schemas.openxmlformats.org/drawingml/2006/main">
               <a:ext uri="{FF2B5EF4-FFF2-40B4-BE49-F238E27FC236}">
-                <a16:creationId xmlns:a16="http://schemas.microsoft.com/office/drawing/2014/main" id="{B2849100-2906-420E-AD13-0E3920019D20}"/>
-              </a:ext>
-            </a:extLst>
-          </p:cNvPr>
-          <p:cNvSpPr>
-            <a:spLocks xmlns:a="http://schemas.openxmlformats.org/drawingml/2006/main" noGrp="1"/>
-          </p:cNvSpPr>
-          <p:nvPr/>
-        </p:nvSpPr>
-        <p:spPr>
-          <a:xfrm xmlns:a="http://schemas.openxmlformats.org/drawingml/2006/main">
-            <a:off x="1200150" y="5619750"/>
-            <a:ext cx="4333875" cy="704850"/>
-          </a:xfrm>
-          <a:prstGeom xmlns:a="http://schemas.openxmlformats.org/drawingml/2006/main" prst="rect">
-            <a:avLst/>
-          </a:prstGeom>
-          <a:solidFill xmlns:a="http://schemas.openxmlformats.org/drawingml/2006/main">
-            <a:srgbClr val="FFFFFF"/>
-          </a:solidFill>
-          <a:ln xmlns:a="http://schemas.openxmlformats.org/drawingml/2006/main" w="9525">
-            <a:solidFill>
-              <a:srgbClr val="DBE4F0"/>
+                <a16:creationId xmlns:a16="http://schemas.microsoft.com/office/drawing/2014/main" id="{6E0041AE-17D2-4616-AB6E-599C3191B0A4}"/>
+              </a:ext>
+            </a:extLst>
+          </p:cNvPr>
+          <p:cNvSpPr>
+            <a:spLocks xmlns:a="http://schemas.openxmlformats.org/drawingml/2006/main" noGrp="1"/>
+          </p:cNvSpPr>
+          <p:nvPr/>
+        </p:nvSpPr>
+        <p:spPr>
+          <a:xfrm xmlns:a="http://schemas.openxmlformats.org/drawingml/2006/main">
+            <a:off x="1200150" y="5676900"/>
+            <a:ext cx="57150" cy="647700"/>
+          </a:xfrm>
+          <a:prstGeom xmlns:a="http://schemas.openxmlformats.org/drawingml/2006/main" prst="rect">
+            <a:avLst/>
+          </a:prstGeom>
+          <a:solidFill xmlns:a="http://schemas.openxmlformats.org/drawingml/2006/main">
+            <a:srgbClr val="EA580C"/>
+          </a:solidFill>
+          <a:ln xmlns:a="http://schemas.openxmlformats.org/drawingml/2006/main" w="0">
+            <a:solidFill>
+              <a:srgbClr val="000000">
+                <a:alpha val="0"/>
+              </a:srgbClr>
             </a:solidFill>
             <a:prstDash val="solid"/>
           </a:ln>
@@ -4525,54 +4496,19 @@
           <p:cNvPr id="8" name="">
             <a:extLst xmlns:a="http://schemas.openxmlformats.org/drawingml/2006/main">
               <a:ext uri="{FF2B5EF4-FFF2-40B4-BE49-F238E27FC236}">
-                <a16:creationId xmlns:a16="http://schemas.microsoft.com/office/drawing/2014/main" id="{BB3072DF-D78F-457B-9A0E-D235DD057466}"/>
-              </a:ext>
-            </a:extLst>
-          </p:cNvPr>
-          <p:cNvSpPr>
-            <a:spLocks xmlns:a="http://schemas.openxmlformats.org/drawingml/2006/main" noGrp="1"/>
-          </p:cNvSpPr>
-          <p:nvPr/>
-        </p:nvSpPr>
-        <p:spPr>
-          <a:xfrm xmlns:a="http://schemas.openxmlformats.org/drawingml/2006/main">
-            <a:off x="1200150" y="5619750"/>
-            <a:ext cx="57150" cy="704850"/>
-          </a:xfrm>
-          <a:prstGeom xmlns:a="http://schemas.openxmlformats.org/drawingml/2006/main" prst="rect">
-            <a:avLst/>
-          </a:prstGeom>
-          <a:solidFill xmlns:a="http://schemas.openxmlformats.org/drawingml/2006/main">
-            <a:srgbClr val="EA580C"/>
-          </a:solidFill>
-          <a:ln xmlns:a="http://schemas.openxmlformats.org/drawingml/2006/main" w="0">
-            <a:solidFill>
-              <a:srgbClr val="000000">
-                <a:alpha val="0"/>
-              </a:srgbClr>
-            </a:solidFill>
-            <a:prstDash val="solid"/>
-          </a:ln>
-        </p:spPr>
-      </p:sp>
-      <p:sp>
-        <p:nvSpPr>
-          <p:cNvPr id="9" name="">
-            <a:extLst xmlns:a="http://schemas.openxmlformats.org/drawingml/2006/main">
-              <a:ext uri="{FF2B5EF4-FFF2-40B4-BE49-F238E27FC236}">
-                <a16:creationId xmlns:a16="http://schemas.microsoft.com/office/drawing/2014/main" id="{8195F4AE-D039-4930-8052-CC8C624D247A}"/>
-              </a:ext>
-            </a:extLst>
-          </p:cNvPr>
-          <p:cNvSpPr>
-            <a:spLocks xmlns:a="http://schemas.openxmlformats.org/drawingml/2006/main" noGrp="1"/>
-          </p:cNvSpPr>
-          <p:nvPr/>
-        </p:nvSpPr>
-        <p:spPr>
-          <a:xfrm xmlns:a="http://schemas.openxmlformats.org/drawingml/2006/main">
-            <a:off x="1409700" y="5791200"/>
-            <a:ext cx="3933825" cy="266700"/>
+                <a16:creationId xmlns:a16="http://schemas.microsoft.com/office/drawing/2014/main" id="{F2115EAA-0240-494D-B390-BB1DBFC07E90}"/>
+              </a:ext>
+            </a:extLst>
+          </p:cNvPr>
+          <p:cNvSpPr>
+            <a:spLocks xmlns:a="http://schemas.openxmlformats.org/drawingml/2006/main" noGrp="1"/>
+          </p:cNvSpPr>
+          <p:nvPr/>
+        </p:nvSpPr>
+        <p:spPr>
+          <a:xfrm xmlns:a="http://schemas.openxmlformats.org/drawingml/2006/main">
+            <a:off x="1409700" y="5848350"/>
+            <a:ext cx="4076700" cy="266700"/>
           </a:xfrm>
           <a:prstGeom xmlns:a="http://schemas.openxmlformats.org/drawingml/2006/main" prst="rect">
             <a:avLst/>
@@ -4621,22 +4557,22 @@
       </p:sp>
       <p:sp>
         <p:nvSpPr>
-          <p:cNvPr id="10" name="">
-            <a:extLst xmlns:a="http://schemas.openxmlformats.org/drawingml/2006/main">
-              <a:ext uri="{FF2B5EF4-FFF2-40B4-BE49-F238E27FC236}">
-                <a16:creationId xmlns:a16="http://schemas.microsoft.com/office/drawing/2014/main" id="{569F72A9-D8DD-4143-B361-EDE0C30B67B7}"/>
-              </a:ext>
-            </a:extLst>
-          </p:cNvPr>
-          <p:cNvSpPr>
-            <a:spLocks xmlns:a="http://schemas.openxmlformats.org/drawingml/2006/main" noGrp="1"/>
-          </p:cNvSpPr>
-          <p:nvPr/>
-        </p:nvSpPr>
-        <p:spPr>
-          <a:xfrm xmlns:a="http://schemas.openxmlformats.org/drawingml/2006/main">
-            <a:off x="1409700" y="6134100"/>
-            <a:ext cx="3933825" cy="38100"/>
+          <p:cNvPr id="9" name="">
+            <a:extLst xmlns:a="http://schemas.openxmlformats.org/drawingml/2006/main">
+              <a:ext uri="{FF2B5EF4-FFF2-40B4-BE49-F238E27FC236}">
+                <a16:creationId xmlns:a16="http://schemas.microsoft.com/office/drawing/2014/main" id="{697479B5-8BCC-4F53-A4F9-A3B67314A557}"/>
+              </a:ext>
+            </a:extLst>
+          </p:cNvPr>
+          <p:cNvSpPr>
+            <a:spLocks xmlns:a="http://schemas.openxmlformats.org/drawingml/2006/main" noGrp="1"/>
+          </p:cNvSpPr>
+          <p:nvPr/>
+        </p:nvSpPr>
+        <p:spPr>
+          <a:xfrm xmlns:a="http://schemas.openxmlformats.org/drawingml/2006/main">
+            <a:off x="1409700" y="6191250"/>
+            <a:ext cx="4076700" cy="-19050"/>
           </a:xfrm>
           <a:prstGeom xmlns:a="http://schemas.openxmlformats.org/drawingml/2006/main" prst="rect">
             <a:avLst/>
@@ -4678,39 +4614,74 @@
                 <a:ea typeface="Aptos"/>
                 <a:cs typeface="Aptos"/>
               </a:rPr>
-              <a:t>Each slice becomes a 2D geometry problem: recover the contour, decide what is inside, and turn that into usable structure.</a:t>
+              <a:t>Each printed layer becomes a 2D geometry problem: contour, inside-outside logic, and a usable path.</a:t>
             </a:r>
           </a:p>
         </p:txBody>
       </p:sp>
       <p:sp>
         <p:nvSpPr>
+          <p:cNvPr id="10" name="">
+            <a:extLst xmlns:a="http://schemas.openxmlformats.org/drawingml/2006/main">
+              <a:ext uri="{FF2B5EF4-FFF2-40B4-BE49-F238E27FC236}">
+                <a16:creationId xmlns:a16="http://schemas.microsoft.com/office/drawing/2014/main" id="{C5358D29-47AD-478C-8C9C-B7D3C5BFEAF7}"/>
+              </a:ext>
+            </a:extLst>
+          </p:cNvPr>
+          <p:cNvSpPr>
+            <a:spLocks xmlns:a="http://schemas.openxmlformats.org/drawingml/2006/main" noGrp="1"/>
+          </p:cNvSpPr>
+          <p:nvPr/>
+        </p:nvSpPr>
+        <p:spPr>
+          <a:xfrm xmlns:a="http://schemas.openxmlformats.org/drawingml/2006/main">
+            <a:off x="6229350" y="5676900"/>
+            <a:ext cx="4438650" cy="647700"/>
+          </a:xfrm>
+          <a:prstGeom xmlns:a="http://schemas.openxmlformats.org/drawingml/2006/main" prst="rect">
+            <a:avLst/>
+          </a:prstGeom>
+          <a:solidFill xmlns:a="http://schemas.openxmlformats.org/drawingml/2006/main">
+            <a:srgbClr val="FFFFFF"/>
+          </a:solidFill>
+          <a:ln xmlns:a="http://schemas.openxmlformats.org/drawingml/2006/main" w="9525">
+            <a:solidFill>
+              <a:srgbClr val="DBE4F0"/>
+            </a:solidFill>
+            <a:prstDash val="solid"/>
+          </a:ln>
+        </p:spPr>
+      </p:sp>
+      <p:sp>
+        <p:nvSpPr>
           <p:cNvPr id="11" name="">
             <a:extLst xmlns:a="http://schemas.openxmlformats.org/drawingml/2006/main">
               <a:ext uri="{FF2B5EF4-FFF2-40B4-BE49-F238E27FC236}">
-                <a16:creationId xmlns:a16="http://schemas.microsoft.com/office/drawing/2014/main" id="{6BADCD9A-5C06-45AC-A5D5-2B2A38A38B6D}"/>
-              </a:ext>
-            </a:extLst>
-          </p:cNvPr>
-          <p:cNvSpPr>
-            <a:spLocks xmlns:a="http://schemas.openxmlformats.org/drawingml/2006/main" noGrp="1"/>
-          </p:cNvSpPr>
-          <p:nvPr/>
-        </p:nvSpPr>
-        <p:spPr>
-          <a:xfrm xmlns:a="http://schemas.openxmlformats.org/drawingml/2006/main">
-            <a:off x="6667500" y="5619750"/>
-            <a:ext cx="4000500" cy="704850"/>
-          </a:xfrm>
-          <a:prstGeom xmlns:a="http://schemas.openxmlformats.org/drawingml/2006/main" prst="rect">
-            <a:avLst/>
-          </a:prstGeom>
-          <a:solidFill xmlns:a="http://schemas.openxmlformats.org/drawingml/2006/main">
-            <a:srgbClr val="FFFFFF"/>
-          </a:solidFill>
-          <a:ln xmlns:a="http://schemas.openxmlformats.org/drawingml/2006/main" w="9525">
-            <a:solidFill>
-              <a:srgbClr val="DBE4F0"/>
+                <a16:creationId xmlns:a16="http://schemas.microsoft.com/office/drawing/2014/main" id="{3A271502-2553-4BDF-9393-54927BF405A5}"/>
+              </a:ext>
+            </a:extLst>
+          </p:cNvPr>
+          <p:cNvSpPr>
+            <a:spLocks xmlns:a="http://schemas.openxmlformats.org/drawingml/2006/main" noGrp="1"/>
+          </p:cNvSpPr>
+          <p:nvPr/>
+        </p:nvSpPr>
+        <p:spPr>
+          <a:xfrm xmlns:a="http://schemas.openxmlformats.org/drawingml/2006/main">
+            <a:off x="6229350" y="5676900"/>
+            <a:ext cx="57150" cy="647700"/>
+          </a:xfrm>
+          <a:prstGeom xmlns:a="http://schemas.openxmlformats.org/drawingml/2006/main" prst="rect">
+            <a:avLst/>
+          </a:prstGeom>
+          <a:solidFill xmlns:a="http://schemas.openxmlformats.org/drawingml/2006/main">
+            <a:srgbClr val="059669"/>
+          </a:solidFill>
+          <a:ln xmlns:a="http://schemas.openxmlformats.org/drawingml/2006/main" w="0">
+            <a:solidFill>
+              <a:srgbClr val="000000">
+                <a:alpha val="0"/>
+              </a:srgbClr>
             </a:solidFill>
             <a:prstDash val="solid"/>
           </a:ln>
@@ -4721,54 +4692,19 @@
           <p:cNvPr id="12" name="">
             <a:extLst xmlns:a="http://schemas.openxmlformats.org/drawingml/2006/main">
               <a:ext uri="{FF2B5EF4-FFF2-40B4-BE49-F238E27FC236}">
-                <a16:creationId xmlns:a16="http://schemas.microsoft.com/office/drawing/2014/main" id="{264CCC67-3210-4CC3-8418-F4695B0AF4F1}"/>
-              </a:ext>
-            </a:extLst>
-          </p:cNvPr>
-          <p:cNvSpPr>
-            <a:spLocks xmlns:a="http://schemas.openxmlformats.org/drawingml/2006/main" noGrp="1"/>
-          </p:cNvSpPr>
-          <p:nvPr/>
-        </p:nvSpPr>
-        <p:spPr>
-          <a:xfrm xmlns:a="http://schemas.openxmlformats.org/drawingml/2006/main">
-            <a:off x="6667500" y="5619750"/>
-            <a:ext cx="57150" cy="704850"/>
-          </a:xfrm>
-          <a:prstGeom xmlns:a="http://schemas.openxmlformats.org/drawingml/2006/main" prst="rect">
-            <a:avLst/>
-          </a:prstGeom>
-          <a:solidFill xmlns:a="http://schemas.openxmlformats.org/drawingml/2006/main">
-            <a:srgbClr val="059669"/>
-          </a:solidFill>
-          <a:ln xmlns:a="http://schemas.openxmlformats.org/drawingml/2006/main" w="0">
-            <a:solidFill>
-              <a:srgbClr val="000000">
-                <a:alpha val="0"/>
-              </a:srgbClr>
-            </a:solidFill>
-            <a:prstDash val="solid"/>
-          </a:ln>
-        </p:spPr>
-      </p:sp>
-      <p:sp>
-        <p:nvSpPr>
-          <p:cNvPr id="13" name="">
-            <a:extLst xmlns:a="http://schemas.openxmlformats.org/drawingml/2006/main">
-              <a:ext uri="{FF2B5EF4-FFF2-40B4-BE49-F238E27FC236}">
-                <a16:creationId xmlns:a16="http://schemas.microsoft.com/office/drawing/2014/main" id="{F043C6B6-434A-4E8E-94F0-6AE5582DF965}"/>
-              </a:ext>
-            </a:extLst>
-          </p:cNvPr>
-          <p:cNvSpPr>
-            <a:spLocks xmlns:a="http://schemas.openxmlformats.org/drawingml/2006/main" noGrp="1"/>
-          </p:cNvSpPr>
-          <p:nvPr/>
-        </p:nvSpPr>
-        <p:spPr>
-          <a:xfrm xmlns:a="http://schemas.openxmlformats.org/drawingml/2006/main">
-            <a:off x="6877050" y="5791200"/>
-            <a:ext cx="3600450" cy="266700"/>
+                <a16:creationId xmlns:a16="http://schemas.microsoft.com/office/drawing/2014/main" id="{B14FAB64-BB91-48C6-A200-ED62542A82A3}"/>
+              </a:ext>
+            </a:extLst>
+          </p:cNvPr>
+          <p:cNvSpPr>
+            <a:spLocks xmlns:a="http://schemas.openxmlformats.org/drawingml/2006/main" noGrp="1"/>
+          </p:cNvSpPr>
+          <p:nvPr/>
+        </p:nvSpPr>
+        <p:spPr>
+          <a:xfrm xmlns:a="http://schemas.openxmlformats.org/drawingml/2006/main">
+            <a:off x="6438900" y="5848350"/>
+            <a:ext cx="4038600" cy="266700"/>
           </a:xfrm>
           <a:prstGeom xmlns:a="http://schemas.openxmlformats.org/drawingml/2006/main" prst="rect">
             <a:avLst/>
@@ -4817,22 +4753,22 @@
       </p:sp>
       <p:sp>
         <p:nvSpPr>
-          <p:cNvPr id="14" name="">
-            <a:extLst xmlns:a="http://schemas.openxmlformats.org/drawingml/2006/main">
-              <a:ext uri="{FF2B5EF4-FFF2-40B4-BE49-F238E27FC236}">
-                <a16:creationId xmlns:a16="http://schemas.microsoft.com/office/drawing/2014/main" id="{047414CD-1217-4BBD-8911-FA1462308434}"/>
-              </a:ext>
-            </a:extLst>
-          </p:cNvPr>
-          <p:cNvSpPr>
-            <a:spLocks xmlns:a="http://schemas.openxmlformats.org/drawingml/2006/main" noGrp="1"/>
-          </p:cNvSpPr>
-          <p:nvPr/>
-        </p:nvSpPr>
-        <p:spPr>
-          <a:xfrm xmlns:a="http://schemas.openxmlformats.org/drawingml/2006/main">
-            <a:off x="6877050" y="6134100"/>
-            <a:ext cx="3600450" cy="38100"/>
+          <p:cNvPr id="13" name="">
+            <a:extLst xmlns:a="http://schemas.openxmlformats.org/drawingml/2006/main">
+              <a:ext uri="{FF2B5EF4-FFF2-40B4-BE49-F238E27FC236}">
+                <a16:creationId xmlns:a16="http://schemas.microsoft.com/office/drawing/2014/main" id="{F33CFF86-7712-4985-A794-E1FF2EE925C8}"/>
+              </a:ext>
+            </a:extLst>
+          </p:cNvPr>
+          <p:cNvSpPr>
+            <a:spLocks xmlns:a="http://schemas.openxmlformats.org/drawingml/2006/main" noGrp="1"/>
+          </p:cNvSpPr>
+          <p:nvPr/>
+        </p:nvSpPr>
+        <p:spPr>
+          <a:xfrm xmlns:a="http://schemas.openxmlformats.org/drawingml/2006/main">
+            <a:off x="6438900" y="6191250"/>
+            <a:ext cx="4038600" cy="-19050"/>
           </a:xfrm>
           <a:prstGeom xmlns:a="http://schemas.openxmlformats.org/drawingml/2006/main" prst="rect">
             <a:avLst/>
@@ -4874,17 +4810,17 @@
                 <a:ea typeface="Aptos"/>
                 <a:cs typeface="Aptos"/>
               </a:rPr>
-              <a:t>This is why hulls, winding, Voronoi, and Delaunay belong in the same pipeline instead of appearing as separate tricks.</a:t>
+              <a:t>That is why boundary recovery and interior structure belong to the same pipeline.</a:t>
             </a:r>
           </a:p>
         </p:txBody>
       </p:sp>
       <p:sp>
         <p:nvSpPr>
-          <p:cNvPr id="15" name="">
-            <a:extLst xmlns:a="http://schemas.openxmlformats.org/drawingml/2006/main">
-              <a:ext uri="{FF2B5EF4-FFF2-40B4-BE49-F238E27FC236}">
-                <a16:creationId xmlns:a16="http://schemas.microsoft.com/office/drawing/2014/main" id="{D810F5FC-2E74-46B1-A4D8-75261210C307}"/>
+          <p:cNvPr id="14" name="">
+            <a:extLst xmlns:a="http://schemas.openxmlformats.org/drawingml/2006/main">
+              <a:ext uri="{FF2B5EF4-FFF2-40B4-BE49-F238E27FC236}">
+                <a16:creationId xmlns:a16="http://schemas.microsoft.com/office/drawing/2014/main" id="{46042CBB-22E3-4DC1-9E37-49888E73E65E}"/>
               </a:ext>
             </a:extLst>
           </p:cNvPr>
@@ -4946,7 +4882,7 @@
     </p:spTree>
     <p:extLst>
       <p:ext uri="{BB962C8B-B14F-4D97-AF65-F5344CB8AC3E}">
-        <p14:creationId xmlns:p14="http://schemas.microsoft.com/office/powerpoint/2010/main" val="2100417788"/>
+        <p14:creationId xmlns:p14="http://schemas.microsoft.com/office/powerpoint/2010/main" val="1696282133"/>
       </p:ext>
     </p:extLst>
   </p:cSld>
@@ -4970,7 +4906,7 @@
           <p:cNvPr id="1" name="">
             <a:extLst xmlns:a="http://schemas.openxmlformats.org/drawingml/2006/main">
               <a:ext uri="{FF2B5EF4-FFF2-40B4-BE49-F238E27FC236}">
-                <a16:creationId xmlns:a16="http://schemas.microsoft.com/office/drawing/2014/main" id="{F980C2C0-82C7-4037-A5E9-5F17EE1DF06F}"/>
+                <a16:creationId xmlns:a16="http://schemas.microsoft.com/office/drawing/2014/main" id="{E4B41116-EE5E-4854-96BD-6EC7B2764A30}"/>
               </a:ext>
             </a:extLst>
           </p:cNvPr>
@@ -5005,7 +4941,7 @@
           <p:cNvPr id="2" name="">
             <a:extLst xmlns:a="http://schemas.openxmlformats.org/drawingml/2006/main">
               <a:ext uri="{FF2B5EF4-FFF2-40B4-BE49-F238E27FC236}">
-                <a16:creationId xmlns:a16="http://schemas.microsoft.com/office/drawing/2014/main" id="{6A3A050E-94EC-409C-9492-DE0257D7F77B}"/>
+                <a16:creationId xmlns:a16="http://schemas.microsoft.com/office/drawing/2014/main" id="{F7B806B5-2A41-4D5F-B543-004CF6B22C6D}"/>
               </a:ext>
             </a:extLst>
           </p:cNvPr>
@@ -5040,7 +4976,7 @@
           <p:cNvPr id="3" name="">
             <a:extLst xmlns:a="http://schemas.openxmlformats.org/drawingml/2006/main">
               <a:ext uri="{FF2B5EF4-FFF2-40B4-BE49-F238E27FC236}">
-                <a16:creationId xmlns:a16="http://schemas.microsoft.com/office/drawing/2014/main" id="{CA0902ED-E244-49BD-B751-C07C68941343}"/>
+                <a16:creationId xmlns:a16="http://schemas.microsoft.com/office/drawing/2014/main" id="{A934CC28-E676-42B8-B07E-3F6ADB70487B}"/>
               </a:ext>
             </a:extLst>
           </p:cNvPr>
@@ -5104,7 +5040,7 @@
           <p:cNvPr id="4" name="">
             <a:extLst xmlns:a="http://schemas.openxmlformats.org/drawingml/2006/main">
               <a:ext uri="{FF2B5EF4-FFF2-40B4-BE49-F238E27FC236}">
-                <a16:creationId xmlns:a16="http://schemas.microsoft.com/office/drawing/2014/main" id="{3CA97C1D-1FCE-4419-A9A1-EB584EF6414F}"/>
+                <a16:creationId xmlns:a16="http://schemas.microsoft.com/office/drawing/2014/main" id="{C88D23C9-9494-4C30-978C-71B4A20731A5}"/>
               </a:ext>
             </a:extLst>
           </p:cNvPr>
@@ -5168,7 +5104,7 @@
           <p:cNvPr id="5" name="">
             <a:extLst xmlns:a="http://schemas.openxmlformats.org/drawingml/2006/main">
               <a:ext uri="{FF2B5EF4-FFF2-40B4-BE49-F238E27FC236}">
-                <a16:creationId xmlns:a16="http://schemas.microsoft.com/office/drawing/2014/main" id="{4B74D60C-9FB2-4D55-8C65-896AF74240E6}"/>
+                <a16:creationId xmlns:a16="http://schemas.microsoft.com/office/drawing/2014/main" id="{AAD76301-435F-4CF2-8000-5B5644604838}"/>
               </a:ext>
             </a:extLst>
           </p:cNvPr>
@@ -5236,7 +5172,7 @@
           <p:nvPr/>
         </p:nvPicPr>
         <p:blipFill>
-          <a:blip xmlns:r="http://schemas.openxmlformats.org/officeDocument/2006/relationships" xmlns:a="http://schemas.openxmlformats.org/drawingml/2006/main" r:embed="R9c827f8db270426e"/>
+          <a:blip xmlns:r="http://schemas.openxmlformats.org/officeDocument/2006/relationships" xmlns:a="http://schemas.openxmlformats.org/drawingml/2006/main" r:embed="R46510f5c5bbc44e0"/>
           <a:stretch xmlns:a="http://schemas.openxmlformats.org/drawingml/2006/main"/>
         </p:blipFill>
         <p:spPr>
@@ -5254,7 +5190,7 @@
           <p:cNvPr id="7" name="">
             <a:extLst xmlns:a="http://schemas.openxmlformats.org/drawingml/2006/main">
               <a:ext uri="{FF2B5EF4-FFF2-40B4-BE49-F238E27FC236}">
-                <a16:creationId xmlns:a16="http://schemas.microsoft.com/office/drawing/2014/main" id="{19F0F083-6DCB-4E0A-A9E7-B57793D69B6A}"/>
+                <a16:creationId xmlns:a16="http://schemas.microsoft.com/office/drawing/2014/main" id="{1AF9DA18-912E-48FB-BA4B-4E62454ACC6F}"/>
               </a:ext>
             </a:extLst>
           </p:cNvPr>
@@ -5287,7 +5223,7 @@
           <p:cNvPr id="8" name="">
             <a:extLst xmlns:a="http://schemas.openxmlformats.org/drawingml/2006/main">
               <a:ext uri="{FF2B5EF4-FFF2-40B4-BE49-F238E27FC236}">
-                <a16:creationId xmlns:a16="http://schemas.microsoft.com/office/drawing/2014/main" id="{03FF4CB6-8946-49C7-9321-7C75BD85B518}"/>
+                <a16:creationId xmlns:a16="http://schemas.microsoft.com/office/drawing/2014/main" id="{E8AFA7E3-F594-48F6-ACCB-D37EAEA585D8}"/>
               </a:ext>
             </a:extLst>
           </p:cNvPr>
@@ -5322,7 +5258,7 @@
           <p:cNvPr id="9" name="">
             <a:extLst xmlns:a="http://schemas.openxmlformats.org/drawingml/2006/main">
               <a:ext uri="{FF2B5EF4-FFF2-40B4-BE49-F238E27FC236}">
-                <a16:creationId xmlns:a16="http://schemas.microsoft.com/office/drawing/2014/main" id="{FDFB654A-8F65-4567-842C-C1770C6B8BDB}"/>
+                <a16:creationId xmlns:a16="http://schemas.microsoft.com/office/drawing/2014/main" id="{E82E795E-47ED-4E61-88F0-5AF0415AD5E2}"/>
               </a:ext>
             </a:extLst>
           </p:cNvPr>
@@ -5386,7 +5322,7 @@
           <p:cNvPr id="10" name="">
             <a:extLst xmlns:a="http://schemas.openxmlformats.org/drawingml/2006/main">
               <a:ext uri="{FF2B5EF4-FFF2-40B4-BE49-F238E27FC236}">
-                <a16:creationId xmlns:a16="http://schemas.microsoft.com/office/drawing/2014/main" id="{D6FD365F-6142-405E-8B0C-B6A620078B86}"/>
+                <a16:creationId xmlns:a16="http://schemas.microsoft.com/office/drawing/2014/main" id="{ED1309B7-4FA6-4029-99A8-0BB6BFDFC82D}"/>
               </a:ext>
             </a:extLst>
           </p:cNvPr>
@@ -5450,7 +5386,7 @@
           <p:cNvPr id="11" name="">
             <a:extLst xmlns:a="http://schemas.openxmlformats.org/drawingml/2006/main">
               <a:ext uri="{FF2B5EF4-FFF2-40B4-BE49-F238E27FC236}">
-                <a16:creationId xmlns:a16="http://schemas.microsoft.com/office/drawing/2014/main" id="{79EB646F-7979-4B0F-A695-DB871FCF1AFF}"/>
+                <a16:creationId xmlns:a16="http://schemas.microsoft.com/office/drawing/2014/main" id="{7C739556-2F09-4612-821B-D223F0A8081B}"/>
               </a:ext>
             </a:extLst>
           </p:cNvPr>
@@ -5483,7 +5419,7 @@
           <p:cNvPr id="12" name="">
             <a:extLst xmlns:a="http://schemas.openxmlformats.org/drawingml/2006/main">
               <a:ext uri="{FF2B5EF4-FFF2-40B4-BE49-F238E27FC236}">
-                <a16:creationId xmlns:a16="http://schemas.microsoft.com/office/drawing/2014/main" id="{E845FAB0-AC6E-4F1D-8DD4-867A88CE25B7}"/>
+                <a16:creationId xmlns:a16="http://schemas.microsoft.com/office/drawing/2014/main" id="{E434534A-6439-48BD-BCAB-221FD6D7630D}"/>
               </a:ext>
             </a:extLst>
           </p:cNvPr>
@@ -5518,7 +5454,7 @@
           <p:cNvPr id="13" name="">
             <a:extLst xmlns:a="http://schemas.openxmlformats.org/drawingml/2006/main">
               <a:ext uri="{FF2B5EF4-FFF2-40B4-BE49-F238E27FC236}">
-                <a16:creationId xmlns:a16="http://schemas.microsoft.com/office/drawing/2014/main" id="{0A51F2F1-B44F-4773-AD91-77979F5118E5}"/>
+                <a16:creationId xmlns:a16="http://schemas.microsoft.com/office/drawing/2014/main" id="{C9765FF2-B275-4B33-A604-03B21119C220}"/>
               </a:ext>
             </a:extLst>
           </p:cNvPr>
@@ -5582,7 +5518,7 @@
           <p:cNvPr id="14" name="">
             <a:extLst xmlns:a="http://schemas.openxmlformats.org/drawingml/2006/main">
               <a:ext uri="{FF2B5EF4-FFF2-40B4-BE49-F238E27FC236}">
-                <a16:creationId xmlns:a16="http://schemas.microsoft.com/office/drawing/2014/main" id="{EBF0F8B7-0195-4CB4-B607-A98B784FC6BF}"/>
+                <a16:creationId xmlns:a16="http://schemas.microsoft.com/office/drawing/2014/main" id="{A4B986C6-016E-470D-8356-B023AF055579}"/>
               </a:ext>
             </a:extLst>
           </p:cNvPr>
@@ -5646,7 +5582,7 @@
           <p:cNvPr id="15" name="">
             <a:extLst xmlns:a="http://schemas.openxmlformats.org/drawingml/2006/main">
               <a:ext uri="{FF2B5EF4-FFF2-40B4-BE49-F238E27FC236}">
-                <a16:creationId xmlns:a16="http://schemas.microsoft.com/office/drawing/2014/main" id="{949294D3-F098-4D73-A24F-D03F35420EF9}"/>
+                <a16:creationId xmlns:a16="http://schemas.microsoft.com/office/drawing/2014/main" id="{251038F9-ADFB-4714-B78F-98C3A08795EE}"/>
               </a:ext>
             </a:extLst>
           </p:cNvPr>
@@ -5708,7 +5644,7 @@
     </p:spTree>
     <p:extLst>
       <p:ext uri="{BB962C8B-B14F-4D97-AF65-F5344CB8AC3E}">
-        <p14:creationId xmlns:p14="http://schemas.microsoft.com/office/powerpoint/2010/main" val="846497852"/>
+        <p14:creationId xmlns:p14="http://schemas.microsoft.com/office/powerpoint/2010/main" val="830545361"/>
       </p:ext>
     </p:extLst>
   </p:cSld>
@@ -5732,7 +5668,7 @@
           <p:cNvPr id="1" name="">
             <a:extLst xmlns:a="http://schemas.openxmlformats.org/drawingml/2006/main">
               <a:ext uri="{FF2B5EF4-FFF2-40B4-BE49-F238E27FC236}">
-                <a16:creationId xmlns:a16="http://schemas.microsoft.com/office/drawing/2014/main" id="{14A53EAF-FD2C-4755-81AA-9B118820EEB9}"/>
+                <a16:creationId xmlns:a16="http://schemas.microsoft.com/office/drawing/2014/main" id="{ACBFC787-4851-45B2-9FCE-D6FA8BAAE5BB}"/>
               </a:ext>
             </a:extLst>
           </p:cNvPr>
@@ -5767,7 +5703,7 @@
           <p:cNvPr id="2" name="">
             <a:extLst xmlns:a="http://schemas.openxmlformats.org/drawingml/2006/main">
               <a:ext uri="{FF2B5EF4-FFF2-40B4-BE49-F238E27FC236}">
-                <a16:creationId xmlns:a16="http://schemas.microsoft.com/office/drawing/2014/main" id="{D17D31B4-6229-43A3-B93F-C288CAB8C45D}"/>
+                <a16:creationId xmlns:a16="http://schemas.microsoft.com/office/drawing/2014/main" id="{A8929F41-510B-4E49-B245-B3319722C5C1}"/>
               </a:ext>
             </a:extLst>
           </p:cNvPr>
@@ -5802,7 +5738,7 @@
           <p:cNvPr id="3" name="">
             <a:extLst xmlns:a="http://schemas.openxmlformats.org/drawingml/2006/main">
               <a:ext uri="{FF2B5EF4-FFF2-40B4-BE49-F238E27FC236}">
-                <a16:creationId xmlns:a16="http://schemas.microsoft.com/office/drawing/2014/main" id="{6027ED49-4C37-4FE5-8010-2EDC132C88C2}"/>
+                <a16:creationId xmlns:a16="http://schemas.microsoft.com/office/drawing/2014/main" id="{83C4D686-38D8-434B-8C05-CF73811C3E1C}"/>
               </a:ext>
             </a:extLst>
           </p:cNvPr>
@@ -5866,7 +5802,7 @@
           <p:cNvPr id="4" name="">
             <a:extLst xmlns:a="http://schemas.openxmlformats.org/drawingml/2006/main">
               <a:ext uri="{FF2B5EF4-FFF2-40B4-BE49-F238E27FC236}">
-                <a16:creationId xmlns:a16="http://schemas.microsoft.com/office/drawing/2014/main" id="{1E0B1C98-8E32-4BBE-87BE-C35FFAA775F2}"/>
+                <a16:creationId xmlns:a16="http://schemas.microsoft.com/office/drawing/2014/main" id="{A9532147-E901-4898-8683-D1672C51F714}"/>
               </a:ext>
             </a:extLst>
           </p:cNvPr>
@@ -5930,7 +5866,7 @@
           <p:cNvPr id="5" name="">
             <a:extLst xmlns:a="http://schemas.openxmlformats.org/drawingml/2006/main">
               <a:ext uri="{FF2B5EF4-FFF2-40B4-BE49-F238E27FC236}">
-                <a16:creationId xmlns:a16="http://schemas.microsoft.com/office/drawing/2014/main" id="{7CA21210-46F2-4BA2-B500-F18CFE48B401}"/>
+                <a16:creationId xmlns:a16="http://schemas.microsoft.com/office/drawing/2014/main" id="{109BBA5B-13DF-418E-9A73-04567DDDBE7C}"/>
               </a:ext>
             </a:extLst>
           </p:cNvPr>
@@ -5998,7 +5934,7 @@
           <p:nvPr/>
         </p:nvPicPr>
         <p:blipFill>
-          <a:blip xmlns:r="http://schemas.openxmlformats.org/officeDocument/2006/relationships" xmlns:a="http://schemas.openxmlformats.org/drawingml/2006/main" r:embed="Reb2c4d5799844622"/>
+          <a:blip xmlns:r="http://schemas.openxmlformats.org/officeDocument/2006/relationships" xmlns:a="http://schemas.openxmlformats.org/drawingml/2006/main" r:embed="R285600596c674ec2"/>
           <a:stretch xmlns:a="http://schemas.openxmlformats.org/drawingml/2006/main"/>
         </p:blipFill>
         <p:spPr>
@@ -6016,7 +5952,7 @@
           <p:cNvPr id="7" name="">
             <a:extLst xmlns:a="http://schemas.openxmlformats.org/drawingml/2006/main">
               <a:ext uri="{FF2B5EF4-FFF2-40B4-BE49-F238E27FC236}">
-                <a16:creationId xmlns:a16="http://schemas.microsoft.com/office/drawing/2014/main" id="{CF12FD7E-C4B8-4249-B069-C0E9C6B0A69F}"/>
+                <a16:creationId xmlns:a16="http://schemas.microsoft.com/office/drawing/2014/main" id="{1BDA7D63-9B01-45FD-A771-5FCA27E8003E}"/>
               </a:ext>
             </a:extLst>
           </p:cNvPr>
@@ -6049,7 +5985,7 @@
           <p:cNvPr id="8" name="">
             <a:extLst xmlns:a="http://schemas.openxmlformats.org/drawingml/2006/main">
               <a:ext uri="{FF2B5EF4-FFF2-40B4-BE49-F238E27FC236}">
-                <a16:creationId xmlns:a16="http://schemas.microsoft.com/office/drawing/2014/main" id="{F23F7964-23B9-4B18-BBAD-ED7D22CAA567}"/>
+                <a16:creationId xmlns:a16="http://schemas.microsoft.com/office/drawing/2014/main" id="{6FF9CAB7-52F2-422B-9DBD-30F86CAA1D69}"/>
               </a:ext>
             </a:extLst>
           </p:cNvPr>
@@ -6084,7 +6020,7 @@
           <p:cNvPr id="9" name="">
             <a:extLst xmlns:a="http://schemas.openxmlformats.org/drawingml/2006/main">
               <a:ext uri="{FF2B5EF4-FFF2-40B4-BE49-F238E27FC236}">
-                <a16:creationId xmlns:a16="http://schemas.microsoft.com/office/drawing/2014/main" id="{33C2588F-674E-4404-B1ED-FB13976F76FF}"/>
+                <a16:creationId xmlns:a16="http://schemas.microsoft.com/office/drawing/2014/main" id="{FB7DCE05-0541-4517-BA14-A0058557CCE7}"/>
               </a:ext>
             </a:extLst>
           </p:cNvPr>
@@ -6148,7 +6084,7 @@
           <p:cNvPr id="10" name="">
             <a:extLst xmlns:a="http://schemas.openxmlformats.org/drawingml/2006/main">
               <a:ext uri="{FF2B5EF4-FFF2-40B4-BE49-F238E27FC236}">
-                <a16:creationId xmlns:a16="http://schemas.microsoft.com/office/drawing/2014/main" id="{DF8DFAE3-4378-4941-86C3-9EC08B4B7C3E}"/>
+                <a16:creationId xmlns:a16="http://schemas.microsoft.com/office/drawing/2014/main" id="{C4BD4DFC-1FFD-49E3-B56A-1E4DA8807F41}"/>
               </a:ext>
             </a:extLst>
           </p:cNvPr>
@@ -6212,7 +6148,7 @@
           <p:cNvPr id="11" name="">
             <a:extLst xmlns:a="http://schemas.openxmlformats.org/drawingml/2006/main">
               <a:ext uri="{FF2B5EF4-FFF2-40B4-BE49-F238E27FC236}">
-                <a16:creationId xmlns:a16="http://schemas.microsoft.com/office/drawing/2014/main" id="{83046C5D-C80A-489B-8F69-1377433D83AA}"/>
+                <a16:creationId xmlns:a16="http://schemas.microsoft.com/office/drawing/2014/main" id="{1EF977FE-BD79-4656-9663-B5F04646DEF6}"/>
               </a:ext>
             </a:extLst>
           </p:cNvPr>
@@ -6245,7 +6181,7 @@
           <p:cNvPr id="12" name="">
             <a:extLst xmlns:a="http://schemas.openxmlformats.org/drawingml/2006/main">
               <a:ext uri="{FF2B5EF4-FFF2-40B4-BE49-F238E27FC236}">
-                <a16:creationId xmlns:a16="http://schemas.microsoft.com/office/drawing/2014/main" id="{52766796-EDFC-4152-9483-8A1C13DC7C05}"/>
+                <a16:creationId xmlns:a16="http://schemas.microsoft.com/office/drawing/2014/main" id="{1E499D66-59E2-4AD7-B1D3-C3DA9F8C0AF1}"/>
               </a:ext>
             </a:extLst>
           </p:cNvPr>
@@ -6280,7 +6216,7 @@
           <p:cNvPr id="13" name="">
             <a:extLst xmlns:a="http://schemas.openxmlformats.org/drawingml/2006/main">
               <a:ext uri="{FF2B5EF4-FFF2-40B4-BE49-F238E27FC236}">
-                <a16:creationId xmlns:a16="http://schemas.microsoft.com/office/drawing/2014/main" id="{55223543-098D-461E-9040-D013ADE4302C}"/>
+                <a16:creationId xmlns:a16="http://schemas.microsoft.com/office/drawing/2014/main" id="{643B0F1D-41FE-4F46-9FEC-A8CB2B13B2A0}"/>
               </a:ext>
             </a:extLst>
           </p:cNvPr>
@@ -6344,7 +6280,7 @@
           <p:cNvPr id="14" name="">
             <a:extLst xmlns:a="http://schemas.openxmlformats.org/drawingml/2006/main">
               <a:ext uri="{FF2B5EF4-FFF2-40B4-BE49-F238E27FC236}">
-                <a16:creationId xmlns:a16="http://schemas.microsoft.com/office/drawing/2014/main" id="{FB025A42-AE78-4A62-8BBA-1BCCD744EB36}"/>
+                <a16:creationId xmlns:a16="http://schemas.microsoft.com/office/drawing/2014/main" id="{4293D199-3875-4DA4-9976-98C967DC5DEA}"/>
               </a:ext>
             </a:extLst>
           </p:cNvPr>
@@ -6408,7 +6344,7 @@
           <p:cNvPr id="15" name="">
             <a:extLst xmlns:a="http://schemas.openxmlformats.org/drawingml/2006/main">
               <a:ext uri="{FF2B5EF4-FFF2-40B4-BE49-F238E27FC236}">
-                <a16:creationId xmlns:a16="http://schemas.microsoft.com/office/drawing/2014/main" id="{22AF377A-4E34-4EE1-A57A-ED15511D01EB}"/>
+                <a16:creationId xmlns:a16="http://schemas.microsoft.com/office/drawing/2014/main" id="{EB603B8F-6083-448C-839D-4F406661E3F9}"/>
               </a:ext>
             </a:extLst>
           </p:cNvPr>
@@ -6441,7 +6377,7 @@
           <p:cNvPr id="16" name="">
             <a:extLst xmlns:a="http://schemas.openxmlformats.org/drawingml/2006/main">
               <a:ext uri="{FF2B5EF4-FFF2-40B4-BE49-F238E27FC236}">
-                <a16:creationId xmlns:a16="http://schemas.microsoft.com/office/drawing/2014/main" id="{6DF9E567-251D-4631-AAE7-C0DF23A61BD0}"/>
+                <a16:creationId xmlns:a16="http://schemas.microsoft.com/office/drawing/2014/main" id="{291E4BD9-64A2-43C3-82A7-509AA1E7F36B}"/>
               </a:ext>
             </a:extLst>
           </p:cNvPr>
@@ -6476,7 +6412,7 @@
           <p:cNvPr id="17" name="">
             <a:extLst xmlns:a="http://schemas.openxmlformats.org/drawingml/2006/main">
               <a:ext uri="{FF2B5EF4-FFF2-40B4-BE49-F238E27FC236}">
-                <a16:creationId xmlns:a16="http://schemas.microsoft.com/office/drawing/2014/main" id="{9E4E0BC3-8ACF-47BD-873E-7DD66C3B9E22}"/>
+                <a16:creationId xmlns:a16="http://schemas.microsoft.com/office/drawing/2014/main" id="{9450F939-7452-4BE8-9C01-F009DE06D703}"/>
               </a:ext>
             </a:extLst>
           </p:cNvPr>
@@ -6540,7 +6476,7 @@
           <p:cNvPr id="18" name="">
             <a:extLst xmlns:a="http://schemas.openxmlformats.org/drawingml/2006/main">
               <a:ext uri="{FF2B5EF4-FFF2-40B4-BE49-F238E27FC236}">
-                <a16:creationId xmlns:a16="http://schemas.microsoft.com/office/drawing/2014/main" id="{C595991A-276B-4302-8E6E-A025760AE2F9}"/>
+                <a16:creationId xmlns:a16="http://schemas.microsoft.com/office/drawing/2014/main" id="{7851AA94-4C88-49C3-B49A-5D1E50BE1179}"/>
               </a:ext>
             </a:extLst>
           </p:cNvPr>
@@ -6604,7 +6540,7 @@
           <p:cNvPr id="19" name="">
             <a:extLst xmlns:a="http://schemas.openxmlformats.org/drawingml/2006/main">
               <a:ext uri="{FF2B5EF4-FFF2-40B4-BE49-F238E27FC236}">
-                <a16:creationId xmlns:a16="http://schemas.microsoft.com/office/drawing/2014/main" id="{083EAD6C-EE83-4EF5-849E-1CF46C05551D}"/>
+                <a16:creationId xmlns:a16="http://schemas.microsoft.com/office/drawing/2014/main" id="{F5E549DF-5A67-4505-96C0-4F49FDB29E31}"/>
               </a:ext>
             </a:extLst>
           </p:cNvPr>
@@ -6666,7 +6602,7 @@
     </p:spTree>
     <p:extLst>
       <p:ext uri="{BB962C8B-B14F-4D97-AF65-F5344CB8AC3E}">
-        <p14:creationId xmlns:p14="http://schemas.microsoft.com/office/powerpoint/2010/main" val="1407623224"/>
+        <p14:creationId xmlns:p14="http://schemas.microsoft.com/office/powerpoint/2010/main" val="55286703"/>
       </p:ext>
     </p:extLst>
   </p:cSld>
@@ -6690,7 +6626,7 @@
           <p:cNvPr id="1" name="">
             <a:extLst xmlns:a="http://schemas.openxmlformats.org/drawingml/2006/main">
               <a:ext uri="{FF2B5EF4-FFF2-40B4-BE49-F238E27FC236}">
-                <a16:creationId xmlns:a16="http://schemas.microsoft.com/office/drawing/2014/main" id="{495E3DBA-1516-4C56-A4BD-24CBE6D50AD6}"/>
+                <a16:creationId xmlns:a16="http://schemas.microsoft.com/office/drawing/2014/main" id="{01B3C611-3294-422E-91DF-7550C7EA9315}"/>
               </a:ext>
             </a:extLst>
           </p:cNvPr>
@@ -6725,7 +6661,7 @@
           <p:cNvPr id="2" name="">
             <a:extLst xmlns:a="http://schemas.openxmlformats.org/drawingml/2006/main">
               <a:ext uri="{FF2B5EF4-FFF2-40B4-BE49-F238E27FC236}">
-                <a16:creationId xmlns:a16="http://schemas.microsoft.com/office/drawing/2014/main" id="{8E90FC5F-ACFB-4F3A-9B26-8DD3CCBC1230}"/>
+                <a16:creationId xmlns:a16="http://schemas.microsoft.com/office/drawing/2014/main" id="{5F6D0BA3-E8E8-4891-AFE5-23F6AE591AB9}"/>
               </a:ext>
             </a:extLst>
           </p:cNvPr>
@@ -6760,7 +6696,7 @@
           <p:cNvPr id="3" name="">
             <a:extLst xmlns:a="http://schemas.openxmlformats.org/drawingml/2006/main">
               <a:ext uri="{FF2B5EF4-FFF2-40B4-BE49-F238E27FC236}">
-                <a16:creationId xmlns:a16="http://schemas.microsoft.com/office/drawing/2014/main" id="{5CD726E5-60DF-4A23-8A1B-7B25AAA4B06F}"/>
+                <a16:creationId xmlns:a16="http://schemas.microsoft.com/office/drawing/2014/main" id="{BC384A1B-FF32-4E30-89C7-162F7D995BE8}"/>
               </a:ext>
             </a:extLst>
           </p:cNvPr>
@@ -6824,7 +6760,7 @@
           <p:cNvPr id="4" name="">
             <a:extLst xmlns:a="http://schemas.openxmlformats.org/drawingml/2006/main">
               <a:ext uri="{FF2B5EF4-FFF2-40B4-BE49-F238E27FC236}">
-                <a16:creationId xmlns:a16="http://schemas.microsoft.com/office/drawing/2014/main" id="{C904D186-CBC7-4587-8AF8-6DA194EF2560}"/>
+                <a16:creationId xmlns:a16="http://schemas.microsoft.com/office/drawing/2014/main" id="{6978D07E-D71C-4556-8D35-437189D4BC05}"/>
               </a:ext>
             </a:extLst>
           </p:cNvPr>
@@ -6888,7 +6824,7 @@
           <p:cNvPr id="5" name="">
             <a:extLst xmlns:a="http://schemas.openxmlformats.org/drawingml/2006/main">
               <a:ext uri="{FF2B5EF4-FFF2-40B4-BE49-F238E27FC236}">
-                <a16:creationId xmlns:a16="http://schemas.microsoft.com/office/drawing/2014/main" id="{AE5278B4-D1E9-40D4-984C-56A8ACE993F4}"/>
+                <a16:creationId xmlns:a16="http://schemas.microsoft.com/office/drawing/2014/main" id="{71EF8745-6D8C-4D4E-8EA5-860868E8E5EF}"/>
               </a:ext>
             </a:extLst>
           </p:cNvPr>
@@ -6956,7 +6892,7 @@
           <p:nvPr/>
         </p:nvPicPr>
         <p:blipFill>
-          <a:blip xmlns:r="http://schemas.openxmlformats.org/officeDocument/2006/relationships" xmlns:a="http://schemas.openxmlformats.org/drawingml/2006/main" r:embed="R2369f715a53a4d00"/>
+          <a:blip xmlns:r="http://schemas.openxmlformats.org/officeDocument/2006/relationships" xmlns:a="http://schemas.openxmlformats.org/drawingml/2006/main" r:embed="R0dec53874fb44fde"/>
           <a:stretch xmlns:a="http://schemas.openxmlformats.org/drawingml/2006/main"/>
         </p:blipFill>
         <p:spPr>
@@ -6974,7 +6910,7 @@
           <p:cNvPr id="7" name="">
             <a:extLst xmlns:a="http://schemas.openxmlformats.org/drawingml/2006/main">
               <a:ext uri="{FF2B5EF4-FFF2-40B4-BE49-F238E27FC236}">
-                <a16:creationId xmlns:a16="http://schemas.microsoft.com/office/drawing/2014/main" id="{9022A8DA-E715-44E0-9F73-B819A60A2181}"/>
+                <a16:creationId xmlns:a16="http://schemas.microsoft.com/office/drawing/2014/main" id="{A01466AF-BC13-4656-8575-9726A30FBA5F}"/>
               </a:ext>
             </a:extLst>
           </p:cNvPr>
@@ -7007,7 +6943,7 @@
           <p:cNvPr id="8" name="">
             <a:extLst xmlns:a="http://schemas.openxmlformats.org/drawingml/2006/main">
               <a:ext uri="{FF2B5EF4-FFF2-40B4-BE49-F238E27FC236}">
-                <a16:creationId xmlns:a16="http://schemas.microsoft.com/office/drawing/2014/main" id="{1966C3B0-FD59-43FC-A0C6-BAA2CF759D90}"/>
+                <a16:creationId xmlns:a16="http://schemas.microsoft.com/office/drawing/2014/main" id="{453F8508-57FF-4437-AE5A-0EBC17FDAF35}"/>
               </a:ext>
             </a:extLst>
           </p:cNvPr>
@@ -7042,7 +6978,7 @@
           <p:cNvPr id="9" name="">
             <a:extLst xmlns:a="http://schemas.openxmlformats.org/drawingml/2006/main">
               <a:ext uri="{FF2B5EF4-FFF2-40B4-BE49-F238E27FC236}">
-                <a16:creationId xmlns:a16="http://schemas.microsoft.com/office/drawing/2014/main" id="{B12ADBC3-3D94-4B9A-9DE1-A896A4D0599D}"/>
+                <a16:creationId xmlns:a16="http://schemas.microsoft.com/office/drawing/2014/main" id="{CE256F3C-7EB5-42D8-A6CE-318C06F3A681}"/>
               </a:ext>
             </a:extLst>
           </p:cNvPr>
@@ -7106,7 +7042,7 @@
           <p:cNvPr id="10" name="">
             <a:extLst xmlns:a="http://schemas.openxmlformats.org/drawingml/2006/main">
               <a:ext uri="{FF2B5EF4-FFF2-40B4-BE49-F238E27FC236}">
-                <a16:creationId xmlns:a16="http://schemas.microsoft.com/office/drawing/2014/main" id="{112E7F80-914C-43F6-926E-4FB58CF853AA}"/>
+                <a16:creationId xmlns:a16="http://schemas.microsoft.com/office/drawing/2014/main" id="{53F39ECE-A241-4E45-9453-F61E60CFF556}"/>
               </a:ext>
             </a:extLst>
           </p:cNvPr>
@@ -7170,7 +7106,7 @@
           <p:cNvPr id="11" name="">
             <a:extLst xmlns:a="http://schemas.openxmlformats.org/drawingml/2006/main">
               <a:ext uri="{FF2B5EF4-FFF2-40B4-BE49-F238E27FC236}">
-                <a16:creationId xmlns:a16="http://schemas.microsoft.com/office/drawing/2014/main" id="{794672E4-45E2-4899-9F5C-107F0FD4AB4D}"/>
+                <a16:creationId xmlns:a16="http://schemas.microsoft.com/office/drawing/2014/main" id="{5B63639A-29C0-42F3-94ED-13DCD84F00B9}"/>
               </a:ext>
             </a:extLst>
           </p:cNvPr>
@@ -7203,7 +7139,7 @@
           <p:cNvPr id="12" name="">
             <a:extLst xmlns:a="http://schemas.openxmlformats.org/drawingml/2006/main">
               <a:ext uri="{FF2B5EF4-FFF2-40B4-BE49-F238E27FC236}">
-                <a16:creationId xmlns:a16="http://schemas.microsoft.com/office/drawing/2014/main" id="{8A8A4560-737B-468E-A895-B87F09489C67}"/>
+                <a16:creationId xmlns:a16="http://schemas.microsoft.com/office/drawing/2014/main" id="{953E9331-559F-452A-A0BB-723340087169}"/>
               </a:ext>
             </a:extLst>
           </p:cNvPr>
@@ -7238,7 +7174,7 @@
           <p:cNvPr id="13" name="">
             <a:extLst xmlns:a="http://schemas.openxmlformats.org/drawingml/2006/main">
               <a:ext uri="{FF2B5EF4-FFF2-40B4-BE49-F238E27FC236}">
-                <a16:creationId xmlns:a16="http://schemas.microsoft.com/office/drawing/2014/main" id="{B38DFF4C-5321-4F2D-BEB9-0AFC28A6C32D}"/>
+                <a16:creationId xmlns:a16="http://schemas.microsoft.com/office/drawing/2014/main" id="{24637FEC-4CD2-48BE-95A3-5D6E70E2687F}"/>
               </a:ext>
             </a:extLst>
           </p:cNvPr>
@@ -7302,7 +7238,7 @@
           <p:cNvPr id="14" name="">
             <a:extLst xmlns:a="http://schemas.openxmlformats.org/drawingml/2006/main">
               <a:ext uri="{FF2B5EF4-FFF2-40B4-BE49-F238E27FC236}">
-                <a16:creationId xmlns:a16="http://schemas.microsoft.com/office/drawing/2014/main" id="{5153EECA-1C2E-4823-8D6A-255B9F7E4DCB}"/>
+                <a16:creationId xmlns:a16="http://schemas.microsoft.com/office/drawing/2014/main" id="{B8D2D115-9015-46CE-A0A3-9A5470F79268}"/>
               </a:ext>
             </a:extLst>
           </p:cNvPr>
@@ -7366,7 +7302,7 @@
           <p:cNvPr id="15" name="">
             <a:extLst xmlns:a="http://schemas.openxmlformats.org/drawingml/2006/main">
               <a:ext uri="{FF2B5EF4-FFF2-40B4-BE49-F238E27FC236}">
-                <a16:creationId xmlns:a16="http://schemas.microsoft.com/office/drawing/2014/main" id="{1EF80D3A-07DD-4E9F-B0BE-8575B2F60E79}"/>
+                <a16:creationId xmlns:a16="http://schemas.microsoft.com/office/drawing/2014/main" id="{C06B713E-76C1-40A1-95DF-0407B6F148C5}"/>
               </a:ext>
             </a:extLst>
           </p:cNvPr>
@@ -7399,7 +7335,7 @@
           <p:cNvPr id="16" name="">
             <a:extLst xmlns:a="http://schemas.openxmlformats.org/drawingml/2006/main">
               <a:ext uri="{FF2B5EF4-FFF2-40B4-BE49-F238E27FC236}">
-                <a16:creationId xmlns:a16="http://schemas.microsoft.com/office/drawing/2014/main" id="{C5D74D45-8622-4F81-8904-91B08A6AA7B6}"/>
+                <a16:creationId xmlns:a16="http://schemas.microsoft.com/office/drawing/2014/main" id="{E20EB65F-0D11-4F08-A7E6-EB0B3D136DFC}"/>
               </a:ext>
             </a:extLst>
           </p:cNvPr>
@@ -7434,7 +7370,7 @@
           <p:cNvPr id="17" name="">
             <a:extLst xmlns:a="http://schemas.openxmlformats.org/drawingml/2006/main">
               <a:ext uri="{FF2B5EF4-FFF2-40B4-BE49-F238E27FC236}">
-                <a16:creationId xmlns:a16="http://schemas.microsoft.com/office/drawing/2014/main" id="{F0F89943-F16D-44E2-80DA-886376F22F12}"/>
+                <a16:creationId xmlns:a16="http://schemas.microsoft.com/office/drawing/2014/main" id="{293A0903-EED9-4943-A07F-355965649B0B}"/>
               </a:ext>
             </a:extLst>
           </p:cNvPr>
@@ -7498,7 +7434,7 @@
           <p:cNvPr id="18" name="">
             <a:extLst xmlns:a="http://schemas.openxmlformats.org/drawingml/2006/main">
               <a:ext uri="{FF2B5EF4-FFF2-40B4-BE49-F238E27FC236}">
-                <a16:creationId xmlns:a16="http://schemas.microsoft.com/office/drawing/2014/main" id="{71375CD9-6D63-4499-BE9D-4546F7B1AE43}"/>
+                <a16:creationId xmlns:a16="http://schemas.microsoft.com/office/drawing/2014/main" id="{08FFD01F-2C3D-42B5-8312-60541EE1E5E3}"/>
               </a:ext>
             </a:extLst>
           </p:cNvPr>
@@ -7562,7 +7498,7 @@
           <p:cNvPr id="19" name="">
             <a:extLst xmlns:a="http://schemas.openxmlformats.org/drawingml/2006/main">
               <a:ext uri="{FF2B5EF4-FFF2-40B4-BE49-F238E27FC236}">
-                <a16:creationId xmlns:a16="http://schemas.microsoft.com/office/drawing/2014/main" id="{C9AD3854-E805-4114-BDA2-6985BC98F049}"/>
+                <a16:creationId xmlns:a16="http://schemas.microsoft.com/office/drawing/2014/main" id="{8F5C7DEE-346B-4EF9-BE88-2D203527FBA1}"/>
               </a:ext>
             </a:extLst>
           </p:cNvPr>
@@ -7624,7 +7560,7 @@
     </p:spTree>
     <p:extLst>
       <p:ext uri="{BB962C8B-B14F-4D97-AF65-F5344CB8AC3E}">
-        <p14:creationId xmlns:p14="http://schemas.microsoft.com/office/powerpoint/2010/main" val="1108810822"/>
+        <p14:creationId xmlns:p14="http://schemas.microsoft.com/office/powerpoint/2010/main" val="1947147404"/>
       </p:ext>
     </p:extLst>
   </p:cSld>
@@ -7648,7 +7584,7 @@
           <p:cNvPr id="1" name="">
             <a:extLst xmlns:a="http://schemas.openxmlformats.org/drawingml/2006/main">
               <a:ext uri="{FF2B5EF4-FFF2-40B4-BE49-F238E27FC236}">
-                <a16:creationId xmlns:a16="http://schemas.microsoft.com/office/drawing/2014/main" id="{9650C90A-215E-4B80-9593-3C0F11E6D5BD}"/>
+                <a16:creationId xmlns:a16="http://schemas.microsoft.com/office/drawing/2014/main" id="{0EA36507-2D23-4B4B-BB6C-2CCBD79C9CB7}"/>
               </a:ext>
             </a:extLst>
           </p:cNvPr>
@@ -7683,7 +7619,7 @@
           <p:cNvPr id="2" name="">
             <a:extLst xmlns:a="http://schemas.openxmlformats.org/drawingml/2006/main">
               <a:ext uri="{FF2B5EF4-FFF2-40B4-BE49-F238E27FC236}">
-                <a16:creationId xmlns:a16="http://schemas.microsoft.com/office/drawing/2014/main" id="{89A3F4D5-E2B5-4BE4-8BD0-9EAD88B6B38B}"/>
+                <a16:creationId xmlns:a16="http://schemas.microsoft.com/office/drawing/2014/main" id="{B58ED4CB-6D43-405A-80CB-BD45F7C58CDC}"/>
               </a:ext>
             </a:extLst>
           </p:cNvPr>
@@ -7718,7 +7654,7 @@
           <p:cNvPr id="3" name="">
             <a:extLst xmlns:a="http://schemas.openxmlformats.org/drawingml/2006/main">
               <a:ext uri="{FF2B5EF4-FFF2-40B4-BE49-F238E27FC236}">
-                <a16:creationId xmlns:a16="http://schemas.microsoft.com/office/drawing/2014/main" id="{637CFB4F-51B0-40C3-BBA1-DB5DDA9A9815}"/>
+                <a16:creationId xmlns:a16="http://schemas.microsoft.com/office/drawing/2014/main" id="{D4B20492-9C11-4B3D-B2D9-0C2F71812B42}"/>
               </a:ext>
             </a:extLst>
           </p:cNvPr>
@@ -7782,7 +7718,7 @@
           <p:cNvPr id="4" name="">
             <a:extLst xmlns:a="http://schemas.openxmlformats.org/drawingml/2006/main">
               <a:ext uri="{FF2B5EF4-FFF2-40B4-BE49-F238E27FC236}">
-                <a16:creationId xmlns:a16="http://schemas.microsoft.com/office/drawing/2014/main" id="{7AAB26C5-C08F-4D71-91D1-060213400357}"/>
+                <a16:creationId xmlns:a16="http://schemas.microsoft.com/office/drawing/2014/main" id="{1691AFEC-3E6B-4BC6-B660-A09E2A29C7B0}"/>
               </a:ext>
             </a:extLst>
           </p:cNvPr>
@@ -7846,7 +7782,7 @@
           <p:cNvPr id="5" name="">
             <a:extLst xmlns:a="http://schemas.openxmlformats.org/drawingml/2006/main">
               <a:ext uri="{FF2B5EF4-FFF2-40B4-BE49-F238E27FC236}">
-                <a16:creationId xmlns:a16="http://schemas.microsoft.com/office/drawing/2014/main" id="{4C284307-D420-4B0E-AFD2-C9A43DBF07A5}"/>
+                <a16:creationId xmlns:a16="http://schemas.microsoft.com/office/drawing/2014/main" id="{C7DA815B-03CD-4DCC-8CA7-D3CE24D66493}"/>
               </a:ext>
             </a:extLst>
           </p:cNvPr>
@@ -7914,7 +7850,7 @@
           <p:nvPr/>
         </p:nvPicPr>
         <p:blipFill>
-          <a:blip xmlns:r="http://schemas.openxmlformats.org/officeDocument/2006/relationships" xmlns:a="http://schemas.openxmlformats.org/drawingml/2006/main" r:embed="Rc4351f30686a44e4"/>
+          <a:blip xmlns:r="http://schemas.openxmlformats.org/officeDocument/2006/relationships" xmlns:a="http://schemas.openxmlformats.org/drawingml/2006/main" r:embed="Rc996837e73824b15"/>
           <a:stretch xmlns:a="http://schemas.openxmlformats.org/drawingml/2006/main"/>
         </p:blipFill>
         <p:spPr>
@@ -7932,7 +7868,7 @@
           <p:cNvPr id="7" name="">
             <a:extLst xmlns:a="http://schemas.openxmlformats.org/drawingml/2006/main">
               <a:ext uri="{FF2B5EF4-FFF2-40B4-BE49-F238E27FC236}">
-                <a16:creationId xmlns:a16="http://schemas.microsoft.com/office/drawing/2014/main" id="{BE312D93-25F9-4648-89D4-D6FF30F8FDA9}"/>
+                <a16:creationId xmlns:a16="http://schemas.microsoft.com/office/drawing/2014/main" id="{5C34C7CC-4698-4082-B4B8-D3AB18BCF766}"/>
               </a:ext>
             </a:extLst>
           </p:cNvPr>
@@ -7965,7 +7901,7 @@
           <p:cNvPr id="8" name="">
             <a:extLst xmlns:a="http://schemas.openxmlformats.org/drawingml/2006/main">
               <a:ext uri="{FF2B5EF4-FFF2-40B4-BE49-F238E27FC236}">
-                <a16:creationId xmlns:a16="http://schemas.microsoft.com/office/drawing/2014/main" id="{FDD2E299-EAE3-46F6-A142-4A0AF5DD38C5}"/>
+                <a16:creationId xmlns:a16="http://schemas.microsoft.com/office/drawing/2014/main" id="{004121B6-EAEF-47AD-B8A7-4CD7B83FEC27}"/>
               </a:ext>
             </a:extLst>
           </p:cNvPr>
@@ -8000,7 +7936,7 @@
           <p:cNvPr id="9" name="">
             <a:extLst xmlns:a="http://schemas.openxmlformats.org/drawingml/2006/main">
               <a:ext uri="{FF2B5EF4-FFF2-40B4-BE49-F238E27FC236}">
-                <a16:creationId xmlns:a16="http://schemas.microsoft.com/office/drawing/2014/main" id="{D923F19F-D8D9-463A-BBC4-61AC4CC93151}"/>
+                <a16:creationId xmlns:a16="http://schemas.microsoft.com/office/drawing/2014/main" id="{C2BC612F-D04D-43BF-BD99-4E09B43FBA33}"/>
               </a:ext>
             </a:extLst>
           </p:cNvPr>
@@ -8064,7 +8000,7 @@
           <p:cNvPr id="10" name="">
             <a:extLst xmlns:a="http://schemas.openxmlformats.org/drawingml/2006/main">
               <a:ext uri="{FF2B5EF4-FFF2-40B4-BE49-F238E27FC236}">
-                <a16:creationId xmlns:a16="http://schemas.microsoft.com/office/drawing/2014/main" id="{E2058334-001A-455F-BE1F-1326E150A88F}"/>
+                <a16:creationId xmlns:a16="http://schemas.microsoft.com/office/drawing/2014/main" id="{E940369A-4BED-4BD7-A944-4A5DA5AF2890}"/>
               </a:ext>
             </a:extLst>
           </p:cNvPr>
@@ -8128,7 +8064,7 @@
           <p:cNvPr id="11" name="">
             <a:extLst xmlns:a="http://schemas.openxmlformats.org/drawingml/2006/main">
               <a:ext uri="{FF2B5EF4-FFF2-40B4-BE49-F238E27FC236}">
-                <a16:creationId xmlns:a16="http://schemas.microsoft.com/office/drawing/2014/main" id="{3411660C-FC19-4597-A9BD-90B0BAC1654B}"/>
+                <a16:creationId xmlns:a16="http://schemas.microsoft.com/office/drawing/2014/main" id="{456B646D-56D0-451C-8F2B-F813F0DD0F07}"/>
               </a:ext>
             </a:extLst>
           </p:cNvPr>
@@ -8161,7 +8097,7 @@
           <p:cNvPr id="12" name="">
             <a:extLst xmlns:a="http://schemas.openxmlformats.org/drawingml/2006/main">
               <a:ext uri="{FF2B5EF4-FFF2-40B4-BE49-F238E27FC236}">
-                <a16:creationId xmlns:a16="http://schemas.microsoft.com/office/drawing/2014/main" id="{9AD128A9-3942-4DC4-9337-9319B40078C4}"/>
+                <a16:creationId xmlns:a16="http://schemas.microsoft.com/office/drawing/2014/main" id="{E77231FA-F587-477F-9438-76D1B355BA0C}"/>
               </a:ext>
             </a:extLst>
           </p:cNvPr>
@@ -8196,7 +8132,7 @@
           <p:cNvPr id="13" name="">
             <a:extLst xmlns:a="http://schemas.openxmlformats.org/drawingml/2006/main">
               <a:ext uri="{FF2B5EF4-FFF2-40B4-BE49-F238E27FC236}">
-                <a16:creationId xmlns:a16="http://schemas.microsoft.com/office/drawing/2014/main" id="{F597D256-E0CF-48BC-A586-E22414B81338}"/>
+                <a16:creationId xmlns:a16="http://schemas.microsoft.com/office/drawing/2014/main" id="{BEA1A357-1401-43CA-910D-1DDB5192BA65}"/>
               </a:ext>
             </a:extLst>
           </p:cNvPr>
@@ -8260,7 +8196,7 @@
           <p:cNvPr id="14" name="">
             <a:extLst xmlns:a="http://schemas.openxmlformats.org/drawingml/2006/main">
               <a:ext uri="{FF2B5EF4-FFF2-40B4-BE49-F238E27FC236}">
-                <a16:creationId xmlns:a16="http://schemas.microsoft.com/office/drawing/2014/main" id="{D88469A7-3B1B-4A95-9F0D-5364852ECBA9}"/>
+                <a16:creationId xmlns:a16="http://schemas.microsoft.com/office/drawing/2014/main" id="{D6163014-0C40-47B1-BCD1-A233DCBA2B9B}"/>
               </a:ext>
             </a:extLst>
           </p:cNvPr>
@@ -8324,7 +8260,7 @@
           <p:cNvPr id="15" name="">
             <a:extLst xmlns:a="http://schemas.openxmlformats.org/drawingml/2006/main">
               <a:ext uri="{FF2B5EF4-FFF2-40B4-BE49-F238E27FC236}">
-                <a16:creationId xmlns:a16="http://schemas.microsoft.com/office/drawing/2014/main" id="{B5F5BFDE-B9DE-47DB-B277-ABC8A9D534D2}"/>
+                <a16:creationId xmlns:a16="http://schemas.microsoft.com/office/drawing/2014/main" id="{BCC07B67-EDEE-4458-91B0-6A6DD4FB34D2}"/>
               </a:ext>
             </a:extLst>
           </p:cNvPr>
@@ -8357,7 +8293,7 @@
           <p:cNvPr id="16" name="">
             <a:extLst xmlns:a="http://schemas.openxmlformats.org/drawingml/2006/main">
               <a:ext uri="{FF2B5EF4-FFF2-40B4-BE49-F238E27FC236}">
-                <a16:creationId xmlns:a16="http://schemas.microsoft.com/office/drawing/2014/main" id="{CFB2B5C1-8460-46A1-8EF2-9063CA13428B}"/>
+                <a16:creationId xmlns:a16="http://schemas.microsoft.com/office/drawing/2014/main" id="{621A2689-49DA-4CE5-A9EE-1123E4C1538D}"/>
               </a:ext>
             </a:extLst>
           </p:cNvPr>
@@ -8392,7 +8328,7 @@
           <p:cNvPr id="17" name="">
             <a:extLst xmlns:a="http://schemas.openxmlformats.org/drawingml/2006/main">
               <a:ext uri="{FF2B5EF4-FFF2-40B4-BE49-F238E27FC236}">
-                <a16:creationId xmlns:a16="http://schemas.microsoft.com/office/drawing/2014/main" id="{C578CD1D-9F10-48FE-82D8-3397F743EEF8}"/>
+                <a16:creationId xmlns:a16="http://schemas.microsoft.com/office/drawing/2014/main" id="{07E2C06C-1168-47B9-A62A-9B3BB4E1C87F}"/>
               </a:ext>
             </a:extLst>
           </p:cNvPr>
@@ -8456,7 +8392,7 @@
           <p:cNvPr id="18" name="">
             <a:extLst xmlns:a="http://schemas.openxmlformats.org/drawingml/2006/main">
               <a:ext uri="{FF2B5EF4-FFF2-40B4-BE49-F238E27FC236}">
-                <a16:creationId xmlns:a16="http://schemas.microsoft.com/office/drawing/2014/main" id="{136152F2-19F0-46B9-89DB-D23E5689501A}"/>
+                <a16:creationId xmlns:a16="http://schemas.microsoft.com/office/drawing/2014/main" id="{B5330FFF-64F2-41A1-8C7F-0FA40F359B12}"/>
               </a:ext>
             </a:extLst>
           </p:cNvPr>
@@ -8520,7 +8456,7 @@
           <p:cNvPr id="19" name="">
             <a:extLst xmlns:a="http://schemas.openxmlformats.org/drawingml/2006/main">
               <a:ext uri="{FF2B5EF4-FFF2-40B4-BE49-F238E27FC236}">
-                <a16:creationId xmlns:a16="http://schemas.microsoft.com/office/drawing/2014/main" id="{5A87B7A1-B1F1-4088-83CB-551DF2D652F3}"/>
+                <a16:creationId xmlns:a16="http://schemas.microsoft.com/office/drawing/2014/main" id="{28C1B8E6-DE26-4C5A-84D1-905BC6F4E89D}"/>
               </a:ext>
             </a:extLst>
           </p:cNvPr>
@@ -8582,7 +8518,7 @@
     </p:spTree>
     <p:extLst>
       <p:ext uri="{BB962C8B-B14F-4D97-AF65-F5344CB8AC3E}">
-        <p14:creationId xmlns:p14="http://schemas.microsoft.com/office/powerpoint/2010/main" val="941772115"/>
+        <p14:creationId xmlns:p14="http://schemas.microsoft.com/office/powerpoint/2010/main" val="475630"/>
       </p:ext>
     </p:extLst>
   </p:cSld>
@@ -8606,7 +8542,7 @@
           <p:cNvPr id="1" name="">
             <a:extLst xmlns:a="http://schemas.openxmlformats.org/drawingml/2006/main">
               <a:ext uri="{FF2B5EF4-FFF2-40B4-BE49-F238E27FC236}">
-                <a16:creationId xmlns:a16="http://schemas.microsoft.com/office/drawing/2014/main" id="{2C686614-10BF-45B8-B882-AF7669A3A351}"/>
+                <a16:creationId xmlns:a16="http://schemas.microsoft.com/office/drawing/2014/main" id="{2FE4A98C-746B-4E9F-801A-DFCE9A7CB650}"/>
               </a:ext>
             </a:extLst>
           </p:cNvPr>
@@ -8641,7 +8577,7 @@
           <p:cNvPr id="2" name="">
             <a:extLst xmlns:a="http://schemas.openxmlformats.org/drawingml/2006/main">
               <a:ext uri="{FF2B5EF4-FFF2-40B4-BE49-F238E27FC236}">
-                <a16:creationId xmlns:a16="http://schemas.microsoft.com/office/drawing/2014/main" id="{4E856B38-715C-40CB-83A6-08205E00F3D6}"/>
+                <a16:creationId xmlns:a16="http://schemas.microsoft.com/office/drawing/2014/main" id="{36FDE27F-DE17-442B-B207-E90A19977063}"/>
               </a:ext>
             </a:extLst>
           </p:cNvPr>
@@ -8676,7 +8612,7 @@
           <p:cNvPr id="3" name="">
             <a:extLst xmlns:a="http://schemas.openxmlformats.org/drawingml/2006/main">
               <a:ext uri="{FF2B5EF4-FFF2-40B4-BE49-F238E27FC236}">
-                <a16:creationId xmlns:a16="http://schemas.microsoft.com/office/drawing/2014/main" id="{AE08EB53-F7CA-4736-9D7D-C8C8EA3598EF}"/>
+                <a16:creationId xmlns:a16="http://schemas.microsoft.com/office/drawing/2014/main" id="{D32CBC3B-5F8A-4062-BC59-3B9CF18851BF}"/>
               </a:ext>
             </a:extLst>
           </p:cNvPr>
@@ -8740,7 +8676,7 @@
           <p:cNvPr id="4" name="">
             <a:extLst xmlns:a="http://schemas.openxmlformats.org/drawingml/2006/main">
               <a:ext uri="{FF2B5EF4-FFF2-40B4-BE49-F238E27FC236}">
-                <a16:creationId xmlns:a16="http://schemas.microsoft.com/office/drawing/2014/main" id="{282AAAD8-15C5-4424-9615-135D48B30EFC}"/>
+                <a16:creationId xmlns:a16="http://schemas.microsoft.com/office/drawing/2014/main" id="{DB0108B1-A843-466B-A256-9E542738DED7}"/>
               </a:ext>
             </a:extLst>
           </p:cNvPr>
@@ -8804,7 +8740,7 @@
           <p:cNvPr id="5" name="">
             <a:extLst xmlns:a="http://schemas.openxmlformats.org/drawingml/2006/main">
               <a:ext uri="{FF2B5EF4-FFF2-40B4-BE49-F238E27FC236}">
-                <a16:creationId xmlns:a16="http://schemas.microsoft.com/office/drawing/2014/main" id="{51759B9A-EBF2-47D6-AF2E-817A93BC93EA}"/>
+                <a16:creationId xmlns:a16="http://schemas.microsoft.com/office/drawing/2014/main" id="{E2337A01-14BF-4FF1-A334-17416D4EBA6A}"/>
               </a:ext>
             </a:extLst>
           </p:cNvPr>
@@ -8872,7 +8808,7 @@
           <p:nvPr/>
         </p:nvPicPr>
         <p:blipFill>
-          <a:blip xmlns:r="http://schemas.openxmlformats.org/officeDocument/2006/relationships" xmlns:a="http://schemas.openxmlformats.org/drawingml/2006/main" r:embed="R2886f59a1d0d4676"/>
+          <a:blip xmlns:r="http://schemas.openxmlformats.org/officeDocument/2006/relationships" xmlns:a="http://schemas.openxmlformats.org/drawingml/2006/main" r:embed="Reb7240e299194edd"/>
           <a:stretch xmlns:a="http://schemas.openxmlformats.org/drawingml/2006/main"/>
         </p:blipFill>
         <p:spPr>
@@ -8890,7 +8826,7 @@
           <p:cNvPr id="7" name="">
             <a:extLst xmlns:a="http://schemas.openxmlformats.org/drawingml/2006/main">
               <a:ext uri="{FF2B5EF4-FFF2-40B4-BE49-F238E27FC236}">
-                <a16:creationId xmlns:a16="http://schemas.microsoft.com/office/drawing/2014/main" id="{417701D5-FC62-4FA5-930A-C3A8DB5D19C6}"/>
+                <a16:creationId xmlns:a16="http://schemas.microsoft.com/office/drawing/2014/main" id="{DC56DBEA-74DE-4197-AEDE-91B2DC406B1C}"/>
               </a:ext>
             </a:extLst>
           </p:cNvPr>
@@ -8923,7 +8859,7 @@
           <p:cNvPr id="8" name="">
             <a:extLst xmlns:a="http://schemas.openxmlformats.org/drawingml/2006/main">
               <a:ext uri="{FF2B5EF4-FFF2-40B4-BE49-F238E27FC236}">
-                <a16:creationId xmlns:a16="http://schemas.microsoft.com/office/drawing/2014/main" id="{E53D404A-1BE7-413B-A812-9C9AFBB6C01E}"/>
+                <a16:creationId xmlns:a16="http://schemas.microsoft.com/office/drawing/2014/main" id="{3D7DCFB2-BF4F-49A1-997D-BA2962359EF7}"/>
               </a:ext>
             </a:extLst>
           </p:cNvPr>
@@ -8958,7 +8894,7 @@
           <p:cNvPr id="9" name="">
             <a:extLst xmlns:a="http://schemas.openxmlformats.org/drawingml/2006/main">
               <a:ext uri="{FF2B5EF4-FFF2-40B4-BE49-F238E27FC236}">
-                <a16:creationId xmlns:a16="http://schemas.microsoft.com/office/drawing/2014/main" id="{B9412CDC-7D3B-4CE7-891D-FDFEAF3E2781}"/>
+                <a16:creationId xmlns:a16="http://schemas.microsoft.com/office/drawing/2014/main" id="{6E5C8A6E-414C-4556-B4E1-3020A6BF0C3A}"/>
               </a:ext>
             </a:extLst>
           </p:cNvPr>
@@ -9022,7 +8958,7 @@
           <p:cNvPr id="10" name="">
             <a:extLst xmlns:a="http://schemas.openxmlformats.org/drawingml/2006/main">
               <a:ext uri="{FF2B5EF4-FFF2-40B4-BE49-F238E27FC236}">
-                <a16:creationId xmlns:a16="http://schemas.microsoft.com/office/drawing/2014/main" id="{DF1EEC33-4BF7-4BC4-A168-96B430C9D2B0}"/>
+                <a16:creationId xmlns:a16="http://schemas.microsoft.com/office/drawing/2014/main" id="{BCE6860B-0E7D-43C9-A0F3-5325949B7BF2}"/>
               </a:ext>
             </a:extLst>
           </p:cNvPr>
@@ -9086,7 +9022,7 @@
           <p:cNvPr id="11" name="">
             <a:extLst xmlns:a="http://schemas.openxmlformats.org/drawingml/2006/main">
               <a:ext uri="{FF2B5EF4-FFF2-40B4-BE49-F238E27FC236}">
-                <a16:creationId xmlns:a16="http://schemas.microsoft.com/office/drawing/2014/main" id="{91D53B9F-A987-4047-BB08-BF6BBD267743}"/>
+                <a16:creationId xmlns:a16="http://schemas.microsoft.com/office/drawing/2014/main" id="{E7142550-07BA-41B8-A76E-0BCFEA69E463}"/>
               </a:ext>
             </a:extLst>
           </p:cNvPr>
@@ -9119,7 +9055,7 @@
           <p:cNvPr id="12" name="">
             <a:extLst xmlns:a="http://schemas.openxmlformats.org/drawingml/2006/main">
               <a:ext uri="{FF2B5EF4-FFF2-40B4-BE49-F238E27FC236}">
-                <a16:creationId xmlns:a16="http://schemas.microsoft.com/office/drawing/2014/main" id="{AB410064-FF4E-4113-945D-724809E43FA8}"/>
+                <a16:creationId xmlns:a16="http://schemas.microsoft.com/office/drawing/2014/main" id="{68367820-8C3F-4F88-80BF-D4C9C6D27998}"/>
               </a:ext>
             </a:extLst>
           </p:cNvPr>
@@ -9154,7 +9090,7 @@
           <p:cNvPr id="13" name="">
             <a:extLst xmlns:a="http://schemas.openxmlformats.org/drawingml/2006/main">
               <a:ext uri="{FF2B5EF4-FFF2-40B4-BE49-F238E27FC236}">
-                <a16:creationId xmlns:a16="http://schemas.microsoft.com/office/drawing/2014/main" id="{5B9FB36A-D069-4674-B874-6E2AB8855263}"/>
+                <a16:creationId xmlns:a16="http://schemas.microsoft.com/office/drawing/2014/main" id="{71347E85-C5FA-46ED-89AC-A32F5C7F04EC}"/>
               </a:ext>
             </a:extLst>
           </p:cNvPr>
@@ -9218,7 +9154,7 @@
           <p:cNvPr id="14" name="">
             <a:extLst xmlns:a="http://schemas.openxmlformats.org/drawingml/2006/main">
               <a:ext uri="{FF2B5EF4-FFF2-40B4-BE49-F238E27FC236}">
-                <a16:creationId xmlns:a16="http://schemas.microsoft.com/office/drawing/2014/main" id="{1E25734E-DCA6-41B2-9AEF-9D4A4E3B66BF}"/>
+                <a16:creationId xmlns:a16="http://schemas.microsoft.com/office/drawing/2014/main" id="{B510DA5B-16F9-4901-A397-4B191CD25326}"/>
               </a:ext>
             </a:extLst>
           </p:cNvPr>
@@ -9282,7 +9218,7 @@
           <p:cNvPr id="15" name="">
             <a:extLst xmlns:a="http://schemas.openxmlformats.org/drawingml/2006/main">
               <a:ext uri="{FF2B5EF4-FFF2-40B4-BE49-F238E27FC236}">
-                <a16:creationId xmlns:a16="http://schemas.microsoft.com/office/drawing/2014/main" id="{92152F84-6195-4217-A266-89601A580BD8}"/>
+                <a16:creationId xmlns:a16="http://schemas.microsoft.com/office/drawing/2014/main" id="{FFF4D1E4-3214-418F-BAB9-77FCC33EBD18}"/>
               </a:ext>
             </a:extLst>
           </p:cNvPr>
@@ -9315,7 +9251,7 @@
           <p:cNvPr id="16" name="">
             <a:extLst xmlns:a="http://schemas.openxmlformats.org/drawingml/2006/main">
               <a:ext uri="{FF2B5EF4-FFF2-40B4-BE49-F238E27FC236}">
-                <a16:creationId xmlns:a16="http://schemas.microsoft.com/office/drawing/2014/main" id="{1B322739-D625-4564-9B4E-2D5AA8F74A85}"/>
+                <a16:creationId xmlns:a16="http://schemas.microsoft.com/office/drawing/2014/main" id="{CEC665DA-1377-418B-A19B-A0E73639D118}"/>
               </a:ext>
             </a:extLst>
           </p:cNvPr>
@@ -9350,7 +9286,7 @@
           <p:cNvPr id="17" name="">
             <a:extLst xmlns:a="http://schemas.openxmlformats.org/drawingml/2006/main">
               <a:ext uri="{FF2B5EF4-FFF2-40B4-BE49-F238E27FC236}">
-                <a16:creationId xmlns:a16="http://schemas.microsoft.com/office/drawing/2014/main" id="{445D781A-CEE1-4E80-91F0-95C0BD0A831B}"/>
+                <a16:creationId xmlns:a16="http://schemas.microsoft.com/office/drawing/2014/main" id="{BD8B10A6-069E-4C0F-ADCC-5AD7DBB46F1A}"/>
               </a:ext>
             </a:extLst>
           </p:cNvPr>
@@ -9414,7 +9350,7 @@
           <p:cNvPr id="18" name="">
             <a:extLst xmlns:a="http://schemas.openxmlformats.org/drawingml/2006/main">
               <a:ext uri="{FF2B5EF4-FFF2-40B4-BE49-F238E27FC236}">
-                <a16:creationId xmlns:a16="http://schemas.microsoft.com/office/drawing/2014/main" id="{6457F4AB-46D4-4374-A6F1-E710E41EEEE0}"/>
+                <a16:creationId xmlns:a16="http://schemas.microsoft.com/office/drawing/2014/main" id="{734C0FC9-05D0-436A-9016-08EC729BE00B}"/>
               </a:ext>
             </a:extLst>
           </p:cNvPr>
@@ -9478,7 +9414,7 @@
           <p:cNvPr id="19" name="">
             <a:extLst xmlns:a="http://schemas.openxmlformats.org/drawingml/2006/main">
               <a:ext uri="{FF2B5EF4-FFF2-40B4-BE49-F238E27FC236}">
-                <a16:creationId xmlns:a16="http://schemas.microsoft.com/office/drawing/2014/main" id="{C79A55BF-7645-417F-A98F-8F32D7800104}"/>
+                <a16:creationId xmlns:a16="http://schemas.microsoft.com/office/drawing/2014/main" id="{D2862683-A855-42AF-ACEA-11EA1525739B}"/>
               </a:ext>
             </a:extLst>
           </p:cNvPr>
@@ -9540,7 +9476,7 @@
     </p:spTree>
     <p:extLst>
       <p:ext uri="{BB962C8B-B14F-4D97-AF65-F5344CB8AC3E}">
-        <p14:creationId xmlns:p14="http://schemas.microsoft.com/office/powerpoint/2010/main" val="1997044"/>
+        <p14:creationId xmlns:p14="http://schemas.microsoft.com/office/powerpoint/2010/main" val="1279445103"/>
       </p:ext>
     </p:extLst>
   </p:cSld>
@@ -9564,7 +9500,7 @@
           <p:cNvPr id="1" name="">
             <a:extLst xmlns:a="http://schemas.openxmlformats.org/drawingml/2006/main">
               <a:ext uri="{FF2B5EF4-FFF2-40B4-BE49-F238E27FC236}">
-                <a16:creationId xmlns:a16="http://schemas.microsoft.com/office/drawing/2014/main" id="{0CFB0A48-BDAA-4239-93C3-C3DCA3B53524}"/>
+                <a16:creationId xmlns:a16="http://schemas.microsoft.com/office/drawing/2014/main" id="{D2ED14E1-C9C1-48DE-B6B2-30BBC455464A}"/>
               </a:ext>
             </a:extLst>
           </p:cNvPr>
@@ -9599,7 +9535,7 @@
           <p:cNvPr id="2" name="">
             <a:extLst xmlns:a="http://schemas.openxmlformats.org/drawingml/2006/main">
               <a:ext uri="{FF2B5EF4-FFF2-40B4-BE49-F238E27FC236}">
-                <a16:creationId xmlns:a16="http://schemas.microsoft.com/office/drawing/2014/main" id="{4CEA7AAB-D205-4A1F-9A22-C06E5BAA3A40}"/>
+                <a16:creationId xmlns:a16="http://schemas.microsoft.com/office/drawing/2014/main" id="{A33C46D9-1AE5-4276-B4C7-5423179E7C51}"/>
               </a:ext>
             </a:extLst>
           </p:cNvPr>
@@ -9634,7 +9570,7 @@
           <p:cNvPr id="3" name="">
             <a:extLst xmlns:a="http://schemas.openxmlformats.org/drawingml/2006/main">
               <a:ext uri="{FF2B5EF4-FFF2-40B4-BE49-F238E27FC236}">
-                <a16:creationId xmlns:a16="http://schemas.microsoft.com/office/drawing/2014/main" id="{E58FD941-EAA0-468B-BC47-244EA340EC25}"/>
+                <a16:creationId xmlns:a16="http://schemas.microsoft.com/office/drawing/2014/main" id="{2F8E9401-9ECE-4E83-8BD2-07D96793F1C5}"/>
               </a:ext>
             </a:extLst>
           </p:cNvPr>
@@ -9698,7 +9634,7 @@
           <p:cNvPr id="4" name="">
             <a:extLst xmlns:a="http://schemas.openxmlformats.org/drawingml/2006/main">
               <a:ext uri="{FF2B5EF4-FFF2-40B4-BE49-F238E27FC236}">
-                <a16:creationId xmlns:a16="http://schemas.microsoft.com/office/drawing/2014/main" id="{FACF1D9F-E089-404F-8723-783F5E0ECBD9}"/>
+                <a16:creationId xmlns:a16="http://schemas.microsoft.com/office/drawing/2014/main" id="{537CFD75-B631-4F9D-8AAB-73001F36D3FC}"/>
               </a:ext>
             </a:extLst>
           </p:cNvPr>
@@ -9762,7 +9698,7 @@
           <p:cNvPr id="5" name="">
             <a:extLst xmlns:a="http://schemas.openxmlformats.org/drawingml/2006/main">
               <a:ext uri="{FF2B5EF4-FFF2-40B4-BE49-F238E27FC236}">
-                <a16:creationId xmlns:a16="http://schemas.microsoft.com/office/drawing/2014/main" id="{F06DF1CD-877D-416D-A816-57477131DAEF}"/>
+                <a16:creationId xmlns:a16="http://schemas.microsoft.com/office/drawing/2014/main" id="{66119A1C-E454-485A-9EBB-C825D6F209B3}"/>
               </a:ext>
             </a:extLst>
           </p:cNvPr>
@@ -9830,7 +9766,7 @@
           <p:nvPr/>
         </p:nvPicPr>
         <p:blipFill>
-          <a:blip xmlns:r="http://schemas.openxmlformats.org/officeDocument/2006/relationships" xmlns:a="http://schemas.openxmlformats.org/drawingml/2006/main" r:embed="R7ddfb761e4c64dac"/>
+          <a:blip xmlns:r="http://schemas.openxmlformats.org/officeDocument/2006/relationships" xmlns:a="http://schemas.openxmlformats.org/drawingml/2006/main" r:embed="R44decc43de4f4eec"/>
           <a:stretch xmlns:a="http://schemas.openxmlformats.org/drawingml/2006/main"/>
         </p:blipFill>
         <p:spPr>
@@ -9848,7 +9784,7 @@
           <p:cNvPr id="7" name="">
             <a:extLst xmlns:a="http://schemas.openxmlformats.org/drawingml/2006/main">
               <a:ext uri="{FF2B5EF4-FFF2-40B4-BE49-F238E27FC236}">
-                <a16:creationId xmlns:a16="http://schemas.microsoft.com/office/drawing/2014/main" id="{9A78A542-7F4C-48CD-A52C-49B136833D91}"/>
+                <a16:creationId xmlns:a16="http://schemas.microsoft.com/office/drawing/2014/main" id="{AD889FB9-9C9A-4E69-9692-E425F80451E8}"/>
               </a:ext>
             </a:extLst>
           </p:cNvPr>
@@ -9881,7 +9817,7 @@
           <p:cNvPr id="8" name="">
             <a:extLst xmlns:a="http://schemas.openxmlformats.org/drawingml/2006/main">
               <a:ext uri="{FF2B5EF4-FFF2-40B4-BE49-F238E27FC236}">
-                <a16:creationId xmlns:a16="http://schemas.microsoft.com/office/drawing/2014/main" id="{392803EF-06BB-48C4-BB82-105AA34F2ADE}"/>
+                <a16:creationId xmlns:a16="http://schemas.microsoft.com/office/drawing/2014/main" id="{B707B609-0A6F-43FD-8EFF-A2B52E2778E3}"/>
               </a:ext>
             </a:extLst>
           </p:cNvPr>
@@ -9916,7 +9852,7 @@
           <p:cNvPr id="9" name="">
             <a:extLst xmlns:a="http://schemas.openxmlformats.org/drawingml/2006/main">
               <a:ext uri="{FF2B5EF4-FFF2-40B4-BE49-F238E27FC236}">
-                <a16:creationId xmlns:a16="http://schemas.microsoft.com/office/drawing/2014/main" id="{27F22F0B-0620-42A5-89A0-4281A1DA1F7A}"/>
+                <a16:creationId xmlns:a16="http://schemas.microsoft.com/office/drawing/2014/main" id="{1E1D24D9-F86F-4D2F-8FF7-126A6A167E0F}"/>
               </a:ext>
             </a:extLst>
           </p:cNvPr>
@@ -9980,7 +9916,7 @@
           <p:cNvPr id="10" name="">
             <a:extLst xmlns:a="http://schemas.openxmlformats.org/drawingml/2006/main">
               <a:ext uri="{FF2B5EF4-FFF2-40B4-BE49-F238E27FC236}">
-                <a16:creationId xmlns:a16="http://schemas.microsoft.com/office/drawing/2014/main" id="{C79297B1-591A-4649-90F6-01AB1DFC6BB7}"/>
+                <a16:creationId xmlns:a16="http://schemas.microsoft.com/office/drawing/2014/main" id="{2A0D0E53-14A4-4794-A98E-A1CEDAD637AF}"/>
               </a:ext>
             </a:extLst>
           </p:cNvPr>
@@ -10044,7 +9980,7 @@
           <p:cNvPr id="11" name="">
             <a:extLst xmlns:a="http://schemas.openxmlformats.org/drawingml/2006/main">
               <a:ext uri="{FF2B5EF4-FFF2-40B4-BE49-F238E27FC236}">
-                <a16:creationId xmlns:a16="http://schemas.microsoft.com/office/drawing/2014/main" id="{5D597F74-695A-4F5D-80C0-CBC1E20FB464}"/>
+                <a16:creationId xmlns:a16="http://schemas.microsoft.com/office/drawing/2014/main" id="{1D8DE7AB-1BE9-403B-BC6D-7804E2B30B46}"/>
               </a:ext>
             </a:extLst>
           </p:cNvPr>
@@ -10077,7 +10013,7 @@
           <p:cNvPr id="12" name="">
             <a:extLst xmlns:a="http://schemas.openxmlformats.org/drawingml/2006/main">
               <a:ext uri="{FF2B5EF4-FFF2-40B4-BE49-F238E27FC236}">
-                <a16:creationId xmlns:a16="http://schemas.microsoft.com/office/drawing/2014/main" id="{610AE758-951E-4D1A-AC09-87CF0CE18C8A}"/>
+                <a16:creationId xmlns:a16="http://schemas.microsoft.com/office/drawing/2014/main" id="{E8B33F49-73EA-4F3D-BEC7-436BA7683E41}"/>
               </a:ext>
             </a:extLst>
           </p:cNvPr>
@@ -10112,7 +10048,7 @@
           <p:cNvPr id="13" name="">
             <a:extLst xmlns:a="http://schemas.openxmlformats.org/drawingml/2006/main">
               <a:ext uri="{FF2B5EF4-FFF2-40B4-BE49-F238E27FC236}">
-                <a16:creationId xmlns:a16="http://schemas.microsoft.com/office/drawing/2014/main" id="{CE07BEC0-DBC9-4DF2-8365-D6E03146B6B4}"/>
+                <a16:creationId xmlns:a16="http://schemas.microsoft.com/office/drawing/2014/main" id="{1EF23661-2F7A-4626-974B-9B90217FBFFD}"/>
               </a:ext>
             </a:extLst>
           </p:cNvPr>
@@ -10176,7 +10112,7 @@
           <p:cNvPr id="14" name="">
             <a:extLst xmlns:a="http://schemas.openxmlformats.org/drawingml/2006/main">
               <a:ext uri="{FF2B5EF4-FFF2-40B4-BE49-F238E27FC236}">
-                <a16:creationId xmlns:a16="http://schemas.microsoft.com/office/drawing/2014/main" id="{BA75F86B-29B5-4D8C-B0AA-28C74DDC7CC2}"/>
+                <a16:creationId xmlns:a16="http://schemas.microsoft.com/office/drawing/2014/main" id="{A889856B-31A2-443D-865C-FEADABE56329}"/>
               </a:ext>
             </a:extLst>
           </p:cNvPr>
@@ -10240,7 +10176,7 @@
           <p:cNvPr id="15" name="">
             <a:extLst xmlns:a="http://schemas.openxmlformats.org/drawingml/2006/main">
               <a:ext uri="{FF2B5EF4-FFF2-40B4-BE49-F238E27FC236}">
-                <a16:creationId xmlns:a16="http://schemas.microsoft.com/office/drawing/2014/main" id="{C82CF543-E8A4-4245-A8DA-589365EBDCCF}"/>
+                <a16:creationId xmlns:a16="http://schemas.microsoft.com/office/drawing/2014/main" id="{777C6FD2-6A22-40A8-AF70-4C436978786F}"/>
               </a:ext>
             </a:extLst>
           </p:cNvPr>
@@ -10302,7 +10238,7 @@
     </p:spTree>
     <p:extLst>
       <p:ext uri="{BB962C8B-B14F-4D97-AF65-F5344CB8AC3E}">
-        <p14:creationId xmlns:p14="http://schemas.microsoft.com/office/powerpoint/2010/main" val="1327711725"/>
+        <p14:creationId xmlns:p14="http://schemas.microsoft.com/office/powerpoint/2010/main" val="1412624176"/>
       </p:ext>
     </p:extLst>
   </p:cSld>
@@ -10326,7 +10262,7 @@
           <p:cNvPr id="1" name="">
             <a:extLst xmlns:a="http://schemas.openxmlformats.org/drawingml/2006/main">
               <a:ext uri="{FF2B5EF4-FFF2-40B4-BE49-F238E27FC236}">
-                <a16:creationId xmlns:a16="http://schemas.microsoft.com/office/drawing/2014/main" id="{2297394E-D775-45FA-BD79-94C0D137EF60}"/>
+                <a16:creationId xmlns:a16="http://schemas.microsoft.com/office/drawing/2014/main" id="{B2CF4024-95A5-4EA6-8C3F-24532CE207B3}"/>
               </a:ext>
             </a:extLst>
           </p:cNvPr>
@@ -10361,7 +10297,7 @@
           <p:cNvPr id="2" name="">
             <a:extLst xmlns:a="http://schemas.openxmlformats.org/drawingml/2006/main">
               <a:ext uri="{FF2B5EF4-FFF2-40B4-BE49-F238E27FC236}">
-                <a16:creationId xmlns:a16="http://schemas.microsoft.com/office/drawing/2014/main" id="{11CA1020-5FE2-4067-B21C-778CC85DAC62}"/>
+                <a16:creationId xmlns:a16="http://schemas.microsoft.com/office/drawing/2014/main" id="{8DAE06C1-695B-4C7C-9CA8-3F65AFDF05D3}"/>
               </a:ext>
             </a:extLst>
           </p:cNvPr>
@@ -10396,7 +10332,7 @@
           <p:cNvPr id="3" name="">
             <a:extLst xmlns:a="http://schemas.openxmlformats.org/drawingml/2006/main">
               <a:ext uri="{FF2B5EF4-FFF2-40B4-BE49-F238E27FC236}">
-                <a16:creationId xmlns:a16="http://schemas.microsoft.com/office/drawing/2014/main" id="{27BE08E7-F3F2-47DE-9415-CA55C4443921}"/>
+                <a16:creationId xmlns:a16="http://schemas.microsoft.com/office/drawing/2014/main" id="{7DA39028-6E8F-47FD-98FB-55F639F019D9}"/>
               </a:ext>
             </a:extLst>
           </p:cNvPr>
@@ -10460,7 +10396,7 @@
           <p:cNvPr id="4" name="">
             <a:extLst xmlns:a="http://schemas.openxmlformats.org/drawingml/2006/main">
               <a:ext uri="{FF2B5EF4-FFF2-40B4-BE49-F238E27FC236}">
-                <a16:creationId xmlns:a16="http://schemas.microsoft.com/office/drawing/2014/main" id="{EEF75257-1A15-410A-9A2B-E70429728EA7}"/>
+                <a16:creationId xmlns:a16="http://schemas.microsoft.com/office/drawing/2014/main" id="{06B53112-9AD8-4D63-A29E-E529EDE0C492}"/>
               </a:ext>
             </a:extLst>
           </p:cNvPr>
@@ -10524,7 +10460,7 @@
           <p:cNvPr id="5" name="">
             <a:extLst xmlns:a="http://schemas.openxmlformats.org/drawingml/2006/main">
               <a:ext uri="{FF2B5EF4-FFF2-40B4-BE49-F238E27FC236}">
-                <a16:creationId xmlns:a16="http://schemas.microsoft.com/office/drawing/2014/main" id="{8DD0ECE8-636F-4B49-A4E2-07C1DB6DA5AD}"/>
+                <a16:creationId xmlns:a16="http://schemas.microsoft.com/office/drawing/2014/main" id="{3956A8CA-AFF9-417E-99F1-3E2703027AA6}"/>
               </a:ext>
             </a:extLst>
           </p:cNvPr>
@@ -10592,7 +10528,7 @@
           <p:nvPr/>
         </p:nvPicPr>
         <p:blipFill>
-          <a:blip xmlns:r="http://schemas.openxmlformats.org/officeDocument/2006/relationships" xmlns:a="http://schemas.openxmlformats.org/drawingml/2006/main" r:embed="R7cf8959bb080405c"/>
+          <a:blip xmlns:r="http://schemas.openxmlformats.org/officeDocument/2006/relationships" xmlns:a="http://schemas.openxmlformats.org/drawingml/2006/main" r:embed="R0ab76dd09c64416b"/>
           <a:stretch xmlns:a="http://schemas.openxmlformats.org/drawingml/2006/main"/>
         </p:blipFill>
         <p:spPr>
@@ -10610,7 +10546,7 @@
           <p:cNvPr id="7" name="">
             <a:extLst xmlns:a="http://schemas.openxmlformats.org/drawingml/2006/main">
               <a:ext uri="{FF2B5EF4-FFF2-40B4-BE49-F238E27FC236}">
-                <a16:creationId xmlns:a16="http://schemas.microsoft.com/office/drawing/2014/main" id="{1139546F-D93C-4864-8752-3C2C79D51139}"/>
+                <a16:creationId xmlns:a16="http://schemas.microsoft.com/office/drawing/2014/main" id="{138F3A45-2249-4C4F-B863-A007E1EE0C61}"/>
               </a:ext>
             </a:extLst>
           </p:cNvPr>
@@ -10643,7 +10579,7 @@
           <p:cNvPr id="8" name="">
             <a:extLst xmlns:a="http://schemas.openxmlformats.org/drawingml/2006/main">
               <a:ext uri="{FF2B5EF4-FFF2-40B4-BE49-F238E27FC236}">
-                <a16:creationId xmlns:a16="http://schemas.microsoft.com/office/drawing/2014/main" id="{AB1F9A81-C816-48E4-B9F5-BB919EC4A133}"/>
+                <a16:creationId xmlns:a16="http://schemas.microsoft.com/office/drawing/2014/main" id="{22ABFBFD-85E9-43FC-9EA1-D3C7AEF40B86}"/>
               </a:ext>
             </a:extLst>
           </p:cNvPr>
@@ -10678,7 +10614,7 @@
           <p:cNvPr id="9" name="">
             <a:extLst xmlns:a="http://schemas.openxmlformats.org/drawingml/2006/main">
               <a:ext uri="{FF2B5EF4-FFF2-40B4-BE49-F238E27FC236}">
-                <a16:creationId xmlns:a16="http://schemas.microsoft.com/office/drawing/2014/main" id="{0731AF0E-E000-4660-8605-20716F826339}"/>
+                <a16:creationId xmlns:a16="http://schemas.microsoft.com/office/drawing/2014/main" id="{BF442DE7-850B-4235-96FE-DF70E949E551}"/>
               </a:ext>
             </a:extLst>
           </p:cNvPr>
@@ -10742,7 +10678,7 @@
           <p:cNvPr id="10" name="">
             <a:extLst xmlns:a="http://schemas.openxmlformats.org/drawingml/2006/main">
               <a:ext uri="{FF2B5EF4-FFF2-40B4-BE49-F238E27FC236}">
-                <a16:creationId xmlns:a16="http://schemas.microsoft.com/office/drawing/2014/main" id="{38D2E1F3-E31F-4B89-B4AA-9526C468AB22}"/>
+                <a16:creationId xmlns:a16="http://schemas.microsoft.com/office/drawing/2014/main" id="{285F0EFC-992A-4792-8C24-EC09B61FCDD7}"/>
               </a:ext>
             </a:extLst>
           </p:cNvPr>
@@ -10806,7 +10742,7 @@
           <p:cNvPr id="11" name="">
             <a:extLst xmlns:a="http://schemas.openxmlformats.org/drawingml/2006/main">
               <a:ext uri="{FF2B5EF4-FFF2-40B4-BE49-F238E27FC236}">
-                <a16:creationId xmlns:a16="http://schemas.microsoft.com/office/drawing/2014/main" id="{D96FE429-654B-484E-BFC3-42CC3AD84CF1}"/>
+                <a16:creationId xmlns:a16="http://schemas.microsoft.com/office/drawing/2014/main" id="{B172A85F-7D10-4B37-84A3-67CE3E690C52}"/>
               </a:ext>
             </a:extLst>
           </p:cNvPr>
@@ -10839,7 +10775,7 @@
           <p:cNvPr id="12" name="">
             <a:extLst xmlns:a="http://schemas.openxmlformats.org/drawingml/2006/main">
               <a:ext uri="{FF2B5EF4-FFF2-40B4-BE49-F238E27FC236}">
-                <a16:creationId xmlns:a16="http://schemas.microsoft.com/office/drawing/2014/main" id="{4469E753-3DE3-4984-9BB9-012FBB18FDAB}"/>
+                <a16:creationId xmlns:a16="http://schemas.microsoft.com/office/drawing/2014/main" id="{0E371B7C-E54D-418E-B2EB-4B5A145E7897}"/>
               </a:ext>
             </a:extLst>
           </p:cNvPr>
@@ -10874,7 +10810,7 @@
           <p:cNvPr id="13" name="">
             <a:extLst xmlns:a="http://schemas.openxmlformats.org/drawingml/2006/main">
               <a:ext uri="{FF2B5EF4-FFF2-40B4-BE49-F238E27FC236}">
-                <a16:creationId xmlns:a16="http://schemas.microsoft.com/office/drawing/2014/main" id="{158B8D7D-5C21-4BD7-ABAF-E900AB85FC7E}"/>
+                <a16:creationId xmlns:a16="http://schemas.microsoft.com/office/drawing/2014/main" id="{4AC701F2-6B23-411F-ACE1-9CC1ADB09E4D}"/>
               </a:ext>
             </a:extLst>
           </p:cNvPr>
@@ -10938,7 +10874,7 @@
           <p:cNvPr id="14" name="">
             <a:extLst xmlns:a="http://schemas.openxmlformats.org/drawingml/2006/main">
               <a:ext uri="{FF2B5EF4-FFF2-40B4-BE49-F238E27FC236}">
-                <a16:creationId xmlns:a16="http://schemas.microsoft.com/office/drawing/2014/main" id="{DD041023-D43C-49E7-A0EF-188C589ECE87}"/>
+                <a16:creationId xmlns:a16="http://schemas.microsoft.com/office/drawing/2014/main" id="{5D9EA746-3E54-4212-82FA-06E8451BE857}"/>
               </a:ext>
             </a:extLst>
           </p:cNvPr>
@@ -11002,7 +10938,7 @@
           <p:cNvPr id="15" name="">
             <a:extLst xmlns:a="http://schemas.openxmlformats.org/drawingml/2006/main">
               <a:ext uri="{FF2B5EF4-FFF2-40B4-BE49-F238E27FC236}">
-                <a16:creationId xmlns:a16="http://schemas.microsoft.com/office/drawing/2014/main" id="{83DEF2A4-B8EA-4876-82D6-A8793AE550C9}"/>
+                <a16:creationId xmlns:a16="http://schemas.microsoft.com/office/drawing/2014/main" id="{098FE125-4F46-4E41-ABAE-42B5D8654115}"/>
               </a:ext>
             </a:extLst>
           </p:cNvPr>
@@ -11035,7 +10971,7 @@
           <p:cNvPr id="16" name="">
             <a:extLst xmlns:a="http://schemas.openxmlformats.org/drawingml/2006/main">
               <a:ext uri="{FF2B5EF4-FFF2-40B4-BE49-F238E27FC236}">
-                <a16:creationId xmlns:a16="http://schemas.microsoft.com/office/drawing/2014/main" id="{E2A2835C-F9D3-4788-9742-12299B9EEFAB}"/>
+                <a16:creationId xmlns:a16="http://schemas.microsoft.com/office/drawing/2014/main" id="{CAF3689B-2F03-4BCC-8903-2EDA56BE4178}"/>
               </a:ext>
             </a:extLst>
           </p:cNvPr>
@@ -11070,7 +11006,7 @@
           <p:cNvPr id="17" name="">
             <a:extLst xmlns:a="http://schemas.openxmlformats.org/drawingml/2006/main">
               <a:ext uri="{FF2B5EF4-FFF2-40B4-BE49-F238E27FC236}">
-                <a16:creationId xmlns:a16="http://schemas.microsoft.com/office/drawing/2014/main" id="{0EACCAD5-92EE-41E3-A7C0-EF1ECEA92049}"/>
+                <a16:creationId xmlns:a16="http://schemas.microsoft.com/office/drawing/2014/main" id="{3F15FECA-5B76-499E-955A-1C717B7B00BA}"/>
               </a:ext>
             </a:extLst>
           </p:cNvPr>
@@ -11134,7 +11070,7 @@
           <p:cNvPr id="18" name="">
             <a:extLst xmlns:a="http://schemas.openxmlformats.org/drawingml/2006/main">
               <a:ext uri="{FF2B5EF4-FFF2-40B4-BE49-F238E27FC236}">
-                <a16:creationId xmlns:a16="http://schemas.microsoft.com/office/drawing/2014/main" id="{F4B67E01-9BF5-4E68-A5A8-F237CEFAC7E7}"/>
+                <a16:creationId xmlns:a16="http://schemas.microsoft.com/office/drawing/2014/main" id="{77D3E04F-F971-46A0-8652-A82B3DBCAC68}"/>
               </a:ext>
             </a:extLst>
           </p:cNvPr>
@@ -11198,7 +11134,7 @@
           <p:cNvPr id="19" name="">
             <a:extLst xmlns:a="http://schemas.openxmlformats.org/drawingml/2006/main">
               <a:ext uri="{FF2B5EF4-FFF2-40B4-BE49-F238E27FC236}">
-                <a16:creationId xmlns:a16="http://schemas.microsoft.com/office/drawing/2014/main" id="{F3221C3C-24D9-40B0-B168-40861CF6309B}"/>
+                <a16:creationId xmlns:a16="http://schemas.microsoft.com/office/drawing/2014/main" id="{D1015E68-0BFC-45BD-9506-99AFD8BE091C}"/>
               </a:ext>
             </a:extLst>
           </p:cNvPr>
@@ -11260,7 +11196,7 @@
     </p:spTree>
     <p:extLst>
       <p:ext uri="{BB962C8B-B14F-4D97-AF65-F5344CB8AC3E}">
-        <p14:creationId xmlns:p14="http://schemas.microsoft.com/office/powerpoint/2010/main" val="1848225601"/>
+        <p14:creationId xmlns:p14="http://schemas.microsoft.com/office/powerpoint/2010/main" val="903717466"/>
       </p:ext>
     </p:extLst>
   </p:cSld>

</xml_diff>